<commit_message>
Add AMA in-text citations to Outbreak of the Day deck
Superscript citation numerals keyed to the numbered reference list,
per-slide reference footers, italic journal abbreviations, He et al.
correction note, and source-accuracy fixes on slides 4, 5, 14 and 17.

Co-Authored-By: Claude Opus 5.5 <noreply@anthropic.com>
Claude-Session: https://claude.ai/code/session_01P9P15cYAyKTkYNvJxrcFNV
</commit_message>
<xml_diff>
--- a/Outbreak_of_the_Day/Covid19_Aircraft_Carrier_Outbreak.pptx
+++ b/Outbreak_of_the_Day/Covid19_Aircraft_Carrier_Outbreak.pptx
@@ -127,37 +127,37 @@
   <p:extLst>
     <p:ext uri="{521415D9-36F7-43E2-AB2F-B90AF26B5E84}">
       <p14:sectionLst xmlns:p14="http://schemas.microsoft.com/office/powerpoint/2010/main">
-        <p14:section name="Title" id="{d1d0ed35-b77e-7597-9fa5-11017e656f33}">
+        <p14:section name="Title" id="{953184c3-7e00-2cba-9e66-e48337aeb26d}">
           <p14:sldIdLst>
             <p14:sldId id="256"/>
           </p14:sldIdLst>
         </p14:section>
-        <p14:section name="A. Background &amp; Setting" id="{fa816258-0bd0-d456-1ecf-ed5bedf6a6a8}">
+        <p14:section name="A. Background &amp; Setting" id="{0920f93c-fdbd-5e6f-2613-5ca4a429ee5e}">
           <p14:sldIdLst>
             <p14:sldId id="257"/>
             <p14:sldId id="258"/>
             <p14:sldId id="259"/>
           </p14:sldIdLst>
         </p14:section>
-        <p14:section name="B. Agent &amp; Biology" id="{f2c9c414-0932-9bc6-69ab-e3891572a334}">
+        <p14:section name="B. Agent &amp; Biology" id="{9a1039ba-fb2a-56ec-2db3-74d08a167395}">
           <p14:sldIdLst>
             <p14:sldId id="260"/>
             <p14:sldId id="261"/>
           </p14:sldIdLst>
         </p14:section>
-        <p14:section name="C. Case Definition" id="{24fd76d6-0549-7b2d-f867-5e6b3559100a}">
+        <p14:section name="C. Case Definition" id="{5f344063-ab7a-6c95-9632-ff8baa6850b0}">
           <p14:sldIdLst>
             <p14:sldId id="262"/>
             <p14:sldId id="263"/>
           </p14:sldIdLst>
         </p14:section>
-        <p14:section name="D. Investigation Methods" id="{507aca4b-11de-4f9b-41f4-034cf80ecf9f}">
+        <p14:section name="D. Investigation Methods" id="{c754e0e8-cd35-27d6-a418-587d1ffa7093}">
           <p14:sldIdLst>
             <p14:sldId id="264"/>
             <p14:sldId id="265"/>
           </p14:sldIdLst>
         </p14:section>
-        <p14:section name="E. Epidemiologic Findings" id="{6641f7d5-ef27-8190-3d3a-2fde6766c079}">
+        <p14:section name="E. Epidemiologic Findings" id="{46f0b607-62b5-cab0-9a61-3cafbc1f2c92}">
           <p14:sldIdLst>
             <p14:sldId id="266"/>
             <p14:sldId id="267"/>
@@ -165,33 +165,33 @@
             <p14:sldId id="269"/>
           </p14:sldIdLst>
         </p14:section>
-        <p14:section name="G. Epidemiologic Measures" id="{dd87fa58-0d6b-9e6f-6907-9b70a92c35a5}">
+        <p14:section name="G. Epidemiologic Measures" id="{4bec43b5-2865-d5a7-7cc6-e5ef8c8a8277}">
           <p14:sldIdLst>
             <p14:sldId id="270"/>
             <p14:sldId id="271"/>
           </p14:sldIdLst>
         </p14:section>
-        <p14:section name="H. Interpretation" id="{e27d85fa-877c-55e0-abd6-3c2f76751809}">
+        <p14:section name="H. Interpretation" id="{c2592c22-f1fd-0cc4-f5df-b76fa454b185}">
           <p14:sldIdLst>
             <p14:sldId id="272"/>
           </p14:sldIdLst>
         </p14:section>
-        <p14:section name="K–L. Strengths &amp; Limitations" id="{294f3bb9-2cce-8cdd-8015-c5c62454a078}">
+        <p14:section name="K–L. Strengths &amp; Limitations" id="{cfe5c5f1-542c-1a3d-1a1d-49b5189567ba}">
           <p14:sldIdLst>
             <p14:sldId id="273"/>
           </p14:sldIdLst>
         </p14:section>
-        <p14:section name="M. Recommendations" id="{4b96f40c-76d3-194a-3251-26bfa7339a03}">
+        <p14:section name="M. Recommendations" id="{af0f7a32-b888-4cc5-0fce-94078b908a86}">
           <p14:sldIdLst>
             <p14:sldId id="274"/>
           </p14:sldIdLst>
         </p14:section>
-        <p14:section name="N. Conclusion" id="{7ad9a990-9c3c-4023-1500-8bb5400e0adc}">
+        <p14:section name="N. Conclusion" id="{ac1057f0-83ad-26f2-c42d-4db1e256f5fc}">
           <p14:sldIdLst>
             <p14:sldId id="275"/>
           </p14:sldIdLst>
         </p14:section>
-        <p14:section name="References" id="{0dc95dd1-fe98-8c10-d5ec-f99a750969d7}">
+        <p14:section name="References" id="{60a9a13f-4a5d-25c9-1611-cb3062e112e2}">
           <p14:sldIdLst>
             <p14:sldId id="276"/>
           </p14:sldIdLst>
@@ -231,7 +231,7 @@
                 </a:solidFill>
                 <a:latin typeface="+mn-lt"/>
               </a:rPr>
-              <a:t>Symptoms ever reported, % of symptomatic cases (n = 759)</a:t>
+              <a:t>Symptoms ever reported, % of symptomatic cases (n = 759)¹</a:t>
             </a:r>
           </a:p>
         </c:rich>
@@ -556,7 +556,7 @@
                 </a:solidFill>
                 <a:latin typeface="+mn-lt"/>
               </a:rPr>
-              <a:t>Confirmed and suspected cases by symptom status (N = 1,331)</a:t>
+              <a:t>Confirmed and suspected cases by symptom status (N = 1,331)¹</a:t>
             </a:r>
           </a:p>
         </c:rich>
@@ -874,7 +874,7 @@
                 </a:solidFill>
                 <a:latin typeface="+mn-lt"/>
               </a:rPr>
-              <a:t>Attack rate (confirmed + suspected) by department, %</a:t>
+              <a:t>Attack rate (confirmed + suspected) by department, %, from Table 1 counts¹</a:t>
             </a:r>
           </a:p>
         </c:rich>
@@ -2150,7 +2150,7 @@
           <a:p>
             <a:r>
               <a:rPr lang="en-US" dirty="0"/>
-              <a:t>The epidemic curve shows symptomatic cases by onset date. Sporadic cases appear from March 11, consistent with introduction during the port visit or COD flights about one incubation period earlier. The curve is clearly not a point-source pattern: cases run for more than nine weeks with several peaks, which is the signature of propagated person-to-person transmission. Cases continued well after the crew moved ashore on March 27. That probably reflects infections acquired before quarantine with long incubation, transmission within isolation groups and the skeleton crew aboard, and onset dates recalled after the fact. I'd treat the sharp jump on March 23 cautiously, because that is when active testing began.</a:t>
+              <a:t>The epidemic curve shows symptomatic cases by onset date. Sporadic cases appear from March 11, two to seven days after the port visit, which fits infection in port. The first onsets fall on the same days as the first COD arrivals, so those flights are a less likely source for the first cases, though they could explain later ones. The curve is clearly not a point-source pattern: onsets run for about ten weeks, with a sustained rise and a long, irregular tail, which fits propagated person-to-person transmission. Cases continued well after the ship docked on March 27. That probably reflects infections acquired before quarantine with long incubation, transmission within isolation groups and the skeleton crew aboard, and onset dates recalled after the fact. I'd treat the sharp jump on March 23 cautiously, because that is when active testing began.</a:t>
             </a:r>
             <a:endParaRPr lang="en-US" dirty="0"/>
           </a:p>
@@ -2414,7 +2414,7 @@
           <a:p>
             <a:r>
               <a:rPr lang="en-US" dirty="0"/>
-              <a:t>Putting it together: the most important finding is that silent carriers drove rapid spread in crowded conditions. The source of introduction was never pinned down. The mode of transmission is well supported by several lines of evidence: the propagated curve, the crowding gradient by rank and department, and the lower rate in PPE-protected medical staff. Is the confined-space association causal? Several Bradford Hill criteria support it: strength, consistency with the CDC serosurvey on the same ship, biological plausibility and a gradient. But department is confounded by rank and berthing, the analysis is unadjusted, and many comparisons were made. So I'd call it a strong, plausible association, not proven causation.</a:t>
+              <a:t>Putting it together: the most important finding is that silent carriers and close quarters facilitated rapid spread. The source of introduction was never pinned down. The mode of transmission is well supported by several lines of evidence: the propagated curve, the crowding gradient by rank and department, and the lower rate in PPE-protected medical staff. Is the confined-space association causal? Several Bradford Hill criteria support it: strength, biological plausibility, and consistency with the Navy–CDC serosurvey on the same ship, which tied infection to shared berthing and close contact, although it did not look at work spaces. A dose-response gradient can't be assessed, because confinement was recorded only as confined or mixed. But department is confounded by rank and berthing, the analysis is unadjusted, and many comparisons were made. So I'd call it a strong, plausible association, not proven causation.</a:t>
             </a:r>
             <a:endParaRPr lang="en-US" dirty="0"/>
           </a:p>
@@ -2502,7 +2502,7 @@
           <a:p>
             <a:r>
               <a:rPr lang="en-US" dirty="0"/>
-              <a:t>The investigation's main strength is complete enumeration: every sailor was tested and followed, which removes selection bias and gives true denominators. PCR confirmation and linked health records add rigor. The authors acknowledged weak early records, a changing case definition and limited generalizability. From my own reading, I'd add four more: the analysis is only univariate, so confounding by rank and living quarters wasn't addressed; there was no environmental assessment; symptom data were self-reported and subject to recall bias; and without genomic sequencing the introduction source and transmission chains remain unknown.</a:t>
+              <a:t>The investigation's main strength is complete enumeration: every sailor was tested and followed, which removes selection bias and gives true denominators. PCR confirmation and linked health records add rigor. The authors acknowledged weak early records, a changing case definition and limited generalizability. From my own reading, I'd add five more: the analysis is only univariate, so confounding by rank and living quarters wasn't addressed; no environmental assessment is described; symptom data were self-reported and subject to recall bias; without genomic sequencing the introduction source and transmission chains remain unknown; and the Results text describes percentages calculated on all 1,331 cases as shares of the 1,271 confirmed cases.</a:t>
             </a:r>
             <a:endParaRPr lang="en-US" dirty="0"/>
           </a:p>
@@ -2942,7 +2942,7 @@
           <a:p>
             <a:r>
               <a:rPr lang="en-US" dirty="0"/>
-              <a:t>Context explains the outbreak. A carrier is close to the worst case for respiratory transmission: shared berthing, recirculated air, crowded mess decks. The population is the opposite of high-risk: young, fit and fully immunized. The outbreak was detected when three symptomatic sailors tested positive 13 days into the voyage. Because the Navy tested and followed every crew member, this is a rare outbreak where we know the full denominator and the true proportion of asymptomatic infections.</a:t>
+              <a:t>Context explains the outbreak. A carrier is close to the worst case for respiratory transmission: shared open-bay berthing, densely populated work spaces, crowded galleys and gyms. The population is the opposite of high-risk: young, fit and up to date on routine immunizations, though no Covid-19 vaccine existed yet. The outbreak was detected when three symptomatic sailors tested positive 13 days into the voyage. Because the Navy tested and followed every crew member, this is a rare outbreak where we know the full denominator and have a much more complete estimate of the asymptomatic proportion.</a:t>
             </a:r>
             <a:endParaRPr lang="en-US" dirty="0"/>
           </a:p>
@@ -3030,7 +3030,7 @@
           <a:p>
             <a:r>
               <a:rPr lang="en-US" dirty="0"/>
-              <a:t>Two possible introduction routes appear on the published epidemic curve: a port visit on March 5 to 9 and carrier onboard delivery (COD) flights bringing personnel and mail between March 11 and 17. The investigators did not identify the index case. Looking back, symptoms began as early as March 11, but the outbreak was not recognized until March 23. The ship docked in Guam on March 27 and the crew was moved to isolation or single-room hotel quarantine. Even so, new cases kept occurring until the end of the analysis on May 18.</a:t>
+              <a:t>Two possible introduction routes appear on the published epidemic curve: a port visit on March 5 to 9 and carrier onboard delivery (COD) flights bringing personnel and mail between March 11 and 16. The investigators did not identify the index case. Looking back, symptoms began as early as March 11, but the outbreak was not recognized until March 23. The ship docked in Guam on March 27 and the crew was moved to isolation or single-room hotel quarantine. Even so, new cases kept occurring until the end of the analysis on May 18.</a:t>
             </a:r>
             <a:endParaRPr lang="en-US" dirty="0"/>
           </a:p>
@@ -3118,7 +3118,7 @@
           <a:p>
             <a:r>
               <a:rPr lang="en-US" dirty="0"/>
-              <a:t>SARS-CoV-2 is an enveloped RNA betacoronavirus that enters cells through the ACE2 receptor. Three biological features explain this outbreak. First, it spreads through respiratory droplets and aerosols, which build up in enclosed, poorly ventilated spaces like a ship's interior. Second, infectiousness starts before symptoms; He and colleagues estimated that about 44% of transmission happens in the presymptomatic phase. Third, the incubation period averages about five days but can run up to two weeks, which is why 14-day quarantine was used.</a:t>
+              <a:t>SARS-CoV-2 is an enveloped RNA betacoronavirus that enters cells through the ACE2 receptor. Three biological features explain this outbreak. First, it spreads through respiratory droplets and aerosol particles that can linger in indoor air, as Hu and colleagues describe. Second, infectiousness rises several days before symptoms; in their corrected analysis, He and colleagues estimated that about 44% of transmission happens in the presymptomatic phase. Third, the incubation period averages about five days but can run up to two weeks, which is why 14-day quarantine was used.</a:t>
             </a:r>
             <a:endParaRPr lang="en-US" dirty="0"/>
           </a:p>
@@ -4445,7 +4445,7 @@
                   <a:schemeClr val="accent6"/>
                 </a:solidFill>
               </a:rPr>
-              <a:t>Source: Kasper MR, et al. N Engl J Med. 2020;383:2417-2426.</a:t>
+              <a:t>1. Kasper MR, Geibe JR, Sears CL, et al. N Engl J Med. 2020;383(25):2417-2426.</a:t>
             </a:r>
             <a:endParaRPr lang="en-US" sz="1000" dirty="0"/>
           </a:p>
@@ -4549,7 +4549,7 @@
               </a:rPr>
               <a:t>Isolation</a:t>
             </a:r>
-            <a:endParaRPr lang="en-US" sz="1500" dirty="0"/>
+            <a:endParaRPr lang="en-US" sz="1400" dirty="0"/>
           </a:p>
           <a:p>
             <a:pPr indent="0" marL="0">
@@ -4563,7 +4563,15 @@
               </a:rPr>
               <a:t>Confirmed cases isolated on Naval Base Guam or in the naval hospital; symptoms, temperature and SpO₂ checked twice daily</a:t>
             </a:r>
-            <a:endParaRPr lang="en-US" sz="1500" dirty="0"/>
+            <a:r>
+              <a:rPr lang="en-US" sz="1400" baseline="30000" dirty="0">
+                <a:solidFill>
+                  <a:schemeClr val="tx1"/>
+                </a:solidFill>
+              </a:rPr>
+              <a:t>1</a:t>
+            </a:r>
+            <a:endParaRPr lang="en-US" sz="1400" dirty="0"/>
           </a:p>
         </p:txBody>
       </p:sp>
@@ -4665,7 +4673,7 @@
               </a:rPr>
               <a:t>Quarantine</a:t>
             </a:r>
-            <a:endParaRPr lang="en-US" sz="1500" dirty="0"/>
+            <a:endParaRPr lang="en-US" sz="1400" dirty="0"/>
           </a:p>
           <a:p>
             <a:pPr indent="0" marL="0">
@@ -4679,7 +4687,15 @@
               </a:rPr>
               <a:t>4,079 test-negative, symptom-free crew placed in single-occupancy rooms across 11 hotels</a:t>
             </a:r>
-            <a:endParaRPr lang="en-US" sz="1500" dirty="0"/>
+            <a:r>
+              <a:rPr lang="en-US" sz="1400" baseline="30000" dirty="0">
+                <a:solidFill>
+                  <a:schemeClr val="tx1"/>
+                </a:solidFill>
+              </a:rPr>
+              <a:t>1</a:t>
+            </a:r>
+            <a:endParaRPr lang="en-US" sz="1400" dirty="0"/>
           </a:p>
         </p:txBody>
       </p:sp>
@@ -4781,7 +4797,7 @@
               </a:rPr>
               <a:t>Skeleton crew</a:t>
             </a:r>
-            <a:endParaRPr lang="en-US" sz="1500" dirty="0"/>
+            <a:endParaRPr lang="en-US" sz="1400" dirty="0"/>
           </a:p>
           <a:p>
             <a:pPr indent="0" marL="0">
@@ -4795,7 +4811,15 @@
               </a:rPr>
               <a:t>Essential uninfected personnel stayed aboard to keep the ship running in port</a:t>
             </a:r>
-            <a:endParaRPr lang="en-US" sz="1500" dirty="0"/>
+            <a:r>
+              <a:rPr lang="en-US" sz="1400" baseline="30000" dirty="0">
+                <a:solidFill>
+                  <a:schemeClr val="tx1"/>
+                </a:solidFill>
+              </a:rPr>
+              <a:t>1</a:t>
+            </a:r>
+            <a:endParaRPr lang="en-US" sz="1400" dirty="0"/>
           </a:p>
         </p:txBody>
       </p:sp>
@@ -4897,7 +4921,7 @@
               </a:rPr>
               <a:t>Exit criteria</a:t>
             </a:r>
-            <a:endParaRPr lang="en-US" sz="1500" dirty="0"/>
+            <a:endParaRPr lang="en-US" sz="1400" dirty="0"/>
           </a:p>
           <a:p>
             <a:pPr indent="0" marL="0">
@@ -4911,7 +4935,15 @@
               </a:rPr>
               <a:t>At least 14 days in isolation or quarantine, 3 symptom-free days for cases, and a repeat rRT-PCR before release</a:t>
             </a:r>
-            <a:endParaRPr lang="en-US" sz="1500" dirty="0"/>
+            <a:r>
+              <a:rPr lang="en-US" sz="1400" baseline="30000" dirty="0">
+                <a:solidFill>
+                  <a:schemeClr val="tx1"/>
+                </a:solidFill>
+              </a:rPr>
+              <a:t>1</a:t>
+            </a:r>
+            <a:endParaRPr lang="en-US" sz="1400" dirty="0"/>
           </a:p>
         </p:txBody>
       </p:sp>
@@ -5013,7 +5045,7 @@
               </a:rPr>
               <a:t>Reclassification</a:t>
             </a:r>
-            <a:endParaRPr lang="en-US" sz="1500" dirty="0"/>
+            <a:endParaRPr lang="en-US" sz="1400" dirty="0"/>
           </a:p>
           <a:p>
             <a:pPr indent="0" marL="0">
@@ -5027,7 +5059,15 @@
               </a:rPr>
               <a:t>Anyone who developed symptoms in quarantine was tested and moved to isolation for 14 more days</a:t>
             </a:r>
-            <a:endParaRPr lang="en-US" sz="1500" dirty="0"/>
+            <a:r>
+              <a:rPr lang="en-US" sz="1400" baseline="30000" dirty="0">
+                <a:solidFill>
+                  <a:schemeClr val="tx1"/>
+                </a:solidFill>
+              </a:rPr>
+              <a:t>1</a:t>
+            </a:r>
+            <a:endParaRPr lang="en-US" sz="1400" dirty="0"/>
           </a:p>
         </p:txBody>
       </p:sp>
@@ -5129,7 +5169,7 @@
               </a:rPr>
               <a:t>Follow-up</a:t>
             </a:r>
-            <a:endParaRPr lang="en-US" sz="1500" dirty="0"/>
+            <a:endParaRPr lang="en-US" sz="1400" dirty="0"/>
           </a:p>
           <a:p>
             <a:pPr indent="0" marL="0">
@@ -5143,7 +5183,15 @@
               </a:rPr>
               <a:t>Every crew member followed for at least 10 weeks, whatever their test result</a:t>
             </a:r>
-            <a:endParaRPr lang="en-US" sz="1500" dirty="0"/>
+            <a:r>
+              <a:rPr lang="en-US" sz="1400" baseline="30000" dirty="0">
+                <a:solidFill>
+                  <a:schemeClr val="tx1"/>
+                </a:solidFill>
+              </a:rPr>
+              <a:t>1</a:t>
+            </a:r>
+            <a:endParaRPr lang="en-US" sz="1400" dirty="0"/>
           </a:p>
         </p:txBody>
       </p:sp>
@@ -5290,7 +5338,7 @@
                   <a:schemeClr val="accent6"/>
                 </a:solidFill>
               </a:rPr>
-              <a:t>Source: Kasper MR, et al. N Engl J Med. 2020;383:2417-2426. Percentages: Student calculation from published counts.</a:t>
+              <a:t>1. Kasper MR, Geibe JR, Sears CL, et al. N Engl J Med. 2020;383(25):2417-2426. 45.0%: student calculation from reference 1 data.</a:t>
             </a:r>
             <a:endParaRPr lang="en-US" sz="1000" dirty="0"/>
           </a:p>
@@ -5405,6 +5453,14 @@
               </a:rPr>
               <a:t>of confirmed cases (978/1,271) had no symptoms on the day they tested positive</a:t>
             </a:r>
+            <a:r>
+              <a:rPr lang="en-US" sz="1400" baseline="30000" dirty="0">
+                <a:solidFill>
+                  <a:schemeClr val="tx1"/>
+                </a:solidFill>
+              </a:rPr>
+              <a:t>1</a:t>
+            </a:r>
             <a:endParaRPr lang="en-US" sz="1400" dirty="0"/>
           </a:p>
         </p:txBody>
@@ -5500,7 +5556,7 @@
                   <a:schemeClr val="tx1"/>
                 </a:solidFill>
               </a:rPr>
-              <a:t>of confirmed cases (572/1,271) never developed symptoms</a:t>
+              <a:t>of confirmed cases (572/1,271) never developed symptoms (student calculation)</a:t>
             </a:r>
             <a:endParaRPr lang="en-US" sz="1400" dirty="0"/>
           </a:p>
@@ -5599,6 +5655,14 @@
               </a:rPr>
               <a:t>of confirmed cases (699/1,271) had symptoms at some point</a:t>
             </a:r>
+            <a:r>
+              <a:rPr lang="en-US" sz="1400" baseline="30000" dirty="0">
+                <a:solidFill>
+                  <a:schemeClr val="tx1"/>
+                </a:solidFill>
+              </a:rPr>
+              <a:t>1</a:t>
+            </a:r>
             <a:endParaRPr lang="en-US" sz="1400" dirty="0"/>
           </a:p>
         </p:txBody>
@@ -5635,16 +5699,13 @@
               </a:rPr>
               <a:t>So what? </a:t>
             </a:r>
-            <a:pPr indent="0" marL="0">
-              <a:buNone/>
-            </a:pPr>
             <a:r>
               <a:rPr lang="en-US" sz="1500" dirty="0">
                 <a:solidFill>
                   <a:schemeClr val="tx1"/>
                 </a:solidFill>
               </a:rPr>
-              <a:t>Isolating only symptomatic sailors could not have controlled this outbreak. Most transmission sources were invisible without testing.</a:t>
+              <a:t>Isolating only symptomatic sailors could not have controlled this outbreak. Most infected sailors could not be identified without testing.</a:t>
             </a:r>
             <a:endParaRPr lang="en-US" sz="1500" dirty="0"/>
           </a:p>
@@ -5793,9 +5854,61 @@
                   <a:schemeClr val="accent6"/>
                 </a:solidFill>
               </a:rPr>
-              <a:t>Source: Kasper MR, et al. N Engl J Med. 2020;383:2417-2426. Attack rates: Student calculation from published counts.</a:t>
+              <a:t>1. Kasper MR, Geibe JR, Sears CL, et al. N Engl J Med. 2020;383(25):2417-2426. Attack rates: student calculation from reference 1 data.</a:t>
             </a:r>
             <a:endParaRPr lang="en-US" sz="1000" dirty="0"/>
+          </a:p>
+        </p:txBody>
+      </p:sp>
+      <p:sp>
+        <p:nvSpPr>
+          <p:cNvPr id="4" name="Text 2"/>
+          <p:cNvSpPr txBox="1"/>
+          <p:nvPr/>
+        </p:nvSpPr>
+        <p:spPr>
+          <a:xfrm>
+            <a:off x="548640" y="5532120"/>
+            <a:ext cx="7315200" cy="365760"/>
+          </a:xfrm>
+          <a:prstGeom prst="rect">
+            <a:avLst/>
+          </a:prstGeom>
+          <a:noFill/>
+          <a:ln/>
+        </p:spPr>
+        <p:txBody>
+          <a:bodyPr wrap="square" lIns="635" tIns="635" rIns="635" bIns="635" rtlCol="0" anchor="t"/>
+          <a:lstStyle/>
+          <a:p>
+            <a:pPr indent="0" marL="0">
+              <a:buNone/>
+            </a:pPr>
+            <a:r>
+              <a:rPr lang="en-US" sz="1200" i="1" dirty="0">
+                <a:solidFill>
+                  <a:schemeClr val="accent6"/>
+                </a:solidFill>
+              </a:rPr>
+              <a:t>Table: cases and odds ratios from Kasper et al</a:t>
+            </a:r>
+            <a:r>
+              <a:rPr lang="en-US" sz="1200" i="1" baseline="30000" dirty="0">
+                <a:solidFill>
+                  <a:schemeClr val="accent6"/>
+                </a:solidFill>
+              </a:rPr>
+              <a:t>1</a:t>
+            </a:r>
+            <a:r>
+              <a:rPr lang="en-US" sz="1200" i="1" dirty="0">
+                <a:solidFill>
+                  <a:schemeClr val="accent6"/>
+                </a:solidFill>
+              </a:rPr>
+              <a:t> Table 1; attack rates calculated by the student</a:t>
+            </a:r>
+            <a:endParaRPr lang="en-US" sz="1200" dirty="0"/>
           </a:p>
         </p:txBody>
       </p:sp>
@@ -7951,7 +8064,7 @@
       </p:graphicFrame>
       <p:sp>
         <p:nvSpPr>
-          <p:cNvPr id="5" name="interpretation card"/>
+          <p:cNvPr id="6" name="interpretation card"/>
           <p:cNvSpPr/>
           <p:nvPr/>
         </p:nvSpPr>
@@ -7973,7 +8086,7 @@
       </p:sp>
       <p:sp>
         <p:nvSpPr>
-          <p:cNvPr id="6" name="Text 3"/>
+          <p:cNvPr id="7" name="Text 4"/>
           <p:cNvSpPr txBox="1"/>
           <p:nvPr/>
         </p:nvSpPr>
@@ -8012,7 +8125,7 @@
       </p:sp>
       <p:sp>
         <p:nvSpPr>
-          <p:cNvPr id="7" name="Text 4"/>
+          <p:cNvPr id="8" name="Text 5"/>
           <p:cNvSpPr txBox="1"/>
           <p:nvPr/>
         </p:nvSpPr>
@@ -8062,7 +8175,15 @@
                   <a:schemeClr val="tx1"/>
                 </a:solidFill>
               </a:rPr>
-              <a:t>Enlisted sailors had more risk, most likely because they live in crowded open-bay berthing, unlike officers' smaller staterooms</a:t>
+              <a:t>Enlisted sailors had more risk, most likely because enlisted crew sleep in open bays of tightly spaced bunks</a:t>
+            </a:r>
+            <a:r>
+              <a:rPr lang="en-US" sz="1350" baseline="30000" dirty="0">
+                <a:solidFill>
+                  <a:schemeClr val="tx1"/>
+                </a:solidFill>
+              </a:rPr>
+              <a:t>1</a:t>
             </a:r>
             <a:endParaRPr lang="en-US" sz="1500" dirty="0"/>
           </a:p>
@@ -8082,6 +8203,14 @@
               </a:rPr>
               <a:t>Obesity carried a modest risk; obese sailors were also 35% of those hospitalized</a:t>
             </a:r>
+            <a:r>
+              <a:rPr lang="en-US" sz="1350" baseline="30000" dirty="0">
+                <a:solidFill>
+                  <a:schemeClr val="tx1"/>
+                </a:solidFill>
+              </a:rPr>
+              <a:t>1</a:t>
+            </a:r>
             <a:endParaRPr lang="en-US" sz="1500" dirty="0"/>
           </a:p>
           <a:p>
@@ -8099,6 +8228,14 @@
                 </a:solidFill>
               </a:rPr>
               <a:t>Asthma and hypertension did not affect infection, but were over-represented among the hospitalized (22% each)</a:t>
+            </a:r>
+            <a:r>
+              <a:rPr lang="en-US" sz="1350" baseline="30000" dirty="0">
+                <a:solidFill>
+                  <a:schemeClr val="tx1"/>
+                </a:solidFill>
+              </a:rPr>
+              <a:t>1</a:t>
             </a:r>
             <a:endParaRPr lang="en-US" sz="1500" dirty="0"/>
           </a:p>
@@ -8247,7 +8384,7 @@
                   <a:schemeClr val="accent6"/>
                 </a:solidFill>
               </a:rPr>
-              <a:t>Source: Kasper MR, et al. N Engl J Med. 2020;383:2417-2426. Attack rates and RR: Student calculation from published counts.</a:t>
+              <a:t>1. Kasper MR, Geibe JR, Sears CL, et al. N Engl J Med. 2020;383(25):2417-2426. Attack rates and RR: student calculation from reference 1 data.</a:t>
             </a:r>
             <a:endParaRPr lang="en-US" sz="1000" dirty="0"/>
           </a:p>
@@ -8419,6 +8556,14 @@
                 </a:solidFill>
               </a:rPr>
               <a:t>Medical department: 16.7% (8/48)</a:t>
+            </a:r>
+            <a:r>
+              <a:rPr lang="en-US" sz="1400" b="1" baseline="30000" dirty="0">
+                <a:solidFill>
+                  <a:schemeClr val="tx2"/>
+                </a:solidFill>
+              </a:rPr>
+              <a:t>1</a:t>
             </a:r>
             <a:endParaRPr lang="en-US" sz="1400" dirty="0"/>
           </a:p>
@@ -8581,7 +8726,7 @@
                   <a:schemeClr val="accent6"/>
                 </a:solidFill>
               </a:rPr>
-              <a:t>Figure reproduced from Kasper MR, et al. N Engl J Med. 2020;383:2417-2426 (Figure 2). Interpretation is the student's.</a:t>
+              <a:t>1. Kasper MR, Geibe JR, Sears CL, et al. N Engl J Med. 2020;383(25):2417-2426. Interpretation is the student's.</a:t>
             </a:r>
             <a:endParaRPr lang="en-US" sz="1000" dirty="0"/>
           </a:p>
@@ -8641,7 +8786,23 @@
                   <a:schemeClr val="accent6"/>
                 </a:solidFill>
               </a:rPr>
-              <a:t>Symptomatic confirmed or suspected cases by date of onset (n = 759); asymptomatic cases not shown</a:t>
+              <a:t>Figure: symptomatic confirmed or suspected cases by date of onset (n = 759); asymptomatic cases not shown. Reproduced from Kasper et al</a:t>
+            </a:r>
+            <a:r>
+              <a:rPr lang="en-US" sz="1200" i="1" baseline="30000" dirty="0">
+                <a:solidFill>
+                  <a:schemeClr val="accent6"/>
+                </a:solidFill>
+              </a:rPr>
+              <a:t>1</a:t>
+            </a:r>
+            <a:r>
+              <a:rPr lang="en-US" sz="1200" i="1" dirty="0">
+                <a:solidFill>
+                  <a:schemeClr val="accent6"/>
+                </a:solidFill>
+              </a:rPr>
+              <a:t> (Figure 2).</a:t>
             </a:r>
             <a:endParaRPr lang="en-US" sz="1200" dirty="0"/>
           </a:p>
@@ -8744,16 +8905,29 @@
               </a:rPr>
               <a:t>Introduction: </a:t>
             </a:r>
-            <a:pPr indent="0" marL="0">
-              <a:buNone/>
-            </a:pPr>
             <a:r>
               <a:rPr lang="en-US" sz="1350" dirty="0">
                 <a:solidFill>
                   <a:schemeClr val="tx1"/>
                 </a:solidFill>
               </a:rPr>
-              <a:t>a few cases Mar 11–22, about one incubation period (~5 days) after the port visit and COD flights</a:t>
+              <a:t>first onsets Mar 11–12, 2–7 days after the port visit and on the same days as the first COD arrivals</a:t>
+            </a:r>
+            <a:r>
+              <a:rPr lang="en-US" sz="1350" baseline="30000" dirty="0">
+                <a:solidFill>
+                  <a:schemeClr val="tx1"/>
+                </a:solidFill>
+              </a:rPr>
+              <a:t>1</a:t>
+            </a:r>
+            <a:r>
+              <a:rPr lang="en-US" sz="1350" dirty="0">
+                <a:solidFill>
+                  <a:schemeClr val="tx1"/>
+                </a:solidFill>
+              </a:rPr>
+              <a:t>, so the port visit fits better</a:t>
             </a:r>
             <a:endParaRPr lang="en-US" sz="1500" dirty="0"/>
           </a:p>
@@ -8773,16 +8947,21 @@
               </a:rPr>
               <a:t>Not a point source: </a:t>
             </a:r>
-            <a:pPr indent="0" marL="0">
-              <a:buNone/>
-            </a:pPr>
             <a:r>
               <a:rPr lang="en-US" sz="1350" dirty="0">
                 <a:solidFill>
                   <a:schemeClr val="tx1"/>
                 </a:solidFill>
               </a:rPr>
-              <a:t>cases span more than 9 weeks, far longer than one incubation period</a:t>
+              <a:t>onsets span about 10 weeks, far beyond the 1–14-day incubation range</a:t>
+            </a:r>
+            <a:r>
+              <a:rPr lang="en-US" sz="1350" baseline="30000" dirty="0">
+                <a:solidFill>
+                  <a:schemeClr val="tx1"/>
+                </a:solidFill>
+              </a:rPr>
+              <a:t>2</a:t>
             </a:r>
             <a:endParaRPr lang="en-US" sz="1500" dirty="0"/>
           </a:p>
@@ -8802,16 +8981,13 @@
               </a:rPr>
               <a:t>Propagated: </a:t>
             </a:r>
-            <a:pPr indent="0" marL="0">
-              <a:buNone/>
-            </a:pPr>
             <a:r>
               <a:rPr lang="en-US" sz="1350" dirty="0">
                 <a:solidFill>
                   <a:schemeClr val="tx1"/>
                 </a:solidFill>
               </a:rPr>
-              <a:t>repeated waves (peaks around Mar 30, Apr 13 and May 12) fit person-to-person generations</a:t>
+              <a:t>a sustained rise from Mar 23 and a long, irregular tail into May fit ongoing person-to-person spread</a:t>
             </a:r>
             <a:endParaRPr lang="en-US" sz="1500" dirty="0"/>
           </a:p>
@@ -8831,9 +9007,6 @@
               </a:rPr>
               <a:t>Caution: </a:t>
             </a:r>
-            <a:pPr indent="0" marL="0">
-              <a:buNone/>
-            </a:pPr>
             <a:r>
               <a:rPr lang="en-US" sz="1350" dirty="0">
                 <a:solidFill>
@@ -8989,7 +9162,7 @@
                   <a:schemeClr val="accent6"/>
                 </a:solidFill>
               </a:rPr>
-              <a:t>Source: Kasper MR, et al. N Engl J Med. 2020;383:2417-2426. R = reported by authors; S = student calculation.</a:t>
+              <a:t>1. Kasper MR, Geibe JR, Sears CL, et al. N Engl J Med. 2020;383(25):2417-2426. R = reported in reference 1; S = student calculation from reference 1 data.</a:t>
             </a:r>
             <a:endParaRPr lang="en-US" sz="1000" dirty="0"/>
           </a:p>
@@ -11474,7 +11647,23 @@
                   <a:schemeClr val="tx1"/>
                 </a:solidFill>
               </a:rPr>
-              <a:t>More than 1 in 4 sailors were infected within about 8 weeks: very high transmission</a:t>
+              <a:t>More than 1 in 4 sailors were infected within about 8 weeks</a:t>
+            </a:r>
+            <a:r>
+              <a:rPr lang="en-US" sz="1350" baseline="30000" dirty="0">
+                <a:solidFill>
+                  <a:schemeClr val="tx1"/>
+                </a:solidFill>
+              </a:rPr>
+              <a:t>1</a:t>
+            </a:r>
+            <a:r>
+              <a:rPr lang="en-US" sz="1350" dirty="0">
+                <a:solidFill>
+                  <a:schemeClr val="tx1"/>
+                </a:solidFill>
+              </a:rPr>
+              <a:t>: very high transmission</a:t>
             </a:r>
             <a:endParaRPr lang="en-US" sz="1500" dirty="0"/>
           </a:p>
@@ -11510,7 +11699,7 @@
                   <a:schemeClr val="tx1"/>
                 </a:solidFill>
               </a:rPr>
-              <a:t>Because the whole crew was tested, these are true risks, not estimates from a sample</a:t>
+              <a:t>Because the whole crew was tested there is no sampling error, though some infections may have been missed or misclassified</a:t>
             </a:r>
             <a:endParaRPr lang="en-US" sz="1500" dirty="0"/>
           </a:p>
@@ -11659,7 +11848,7 @@
                   <a:schemeClr val="accent6"/>
                 </a:solidFill>
               </a:rPr>
-              <a:t>Source: Kasper MR, et al. N Engl J Med. 2020;383:2417-2426. Univariate ORs, not adjusted for confounding or multiple comparisons.</a:t>
+              <a:t>1. Kasper MR, Geibe JR, Sears CL, et al. N Engl J Med. 2020;383(25):2417-2426. ORs as reported: univariate, not adjusted.</a:t>
             </a:r>
             <a:endParaRPr lang="en-US" sz="1000" dirty="0"/>
           </a:p>
@@ -11995,6 +12184,14 @@
               </a:rPr>
               <a:t>OR (95% CI)</a:t>
             </a:r>
+            <a:r>
+              <a:rPr lang="en-US" sz="1200" b="1" baseline="30000" dirty="0">
+                <a:solidFill>
+                  <a:schemeClr val="accent6"/>
+                </a:solidFill>
+              </a:rPr>
+              <a:t>1</a:t>
+            </a:r>
             <a:endParaRPr lang="en-US" sz="1200" dirty="0"/>
           </a:p>
         </p:txBody>
@@ -13223,7 +13420,15 @@
                   <a:schemeClr val="tx1"/>
                 </a:solidFill>
               </a:rPr>
-              <a:t>Weapons crew had 2.7 times the odds of infection of air crew</a:t>
+              <a:t>Weapons had the highest reported OR (2.70)</a:t>
+            </a:r>
+            <a:r>
+              <a:rPr lang="en-US" sz="1300" baseline="30000" dirty="0">
+                <a:solidFill>
+                  <a:schemeClr val="tx1"/>
+                </a:solidFill>
+              </a:rPr>
+              <a:t>1</a:t>
             </a:r>
             <a:endParaRPr lang="en-US" sz="1500" dirty="0"/>
           </a:p>
@@ -13243,9 +13448,6 @@
               </a:rPr>
               <a:t>OR ≠ RR here: </a:t>
             </a:r>
-            <a:pPr indent="0" marL="0">
-              <a:buNone/>
-            </a:pPr>
             <a:r>
               <a:rPr lang="en-US" sz="1300" dirty="0">
                 <a:solidFill>
@@ -13401,7 +13603,7 @@
                   <a:schemeClr val="accent6"/>
                 </a:solidFill>
               </a:rPr>
-              <a:t>Student analysis of Kasper MR, et al. 2020; consistency with Payne DC, et al. MMWR. 2020;69:714-721.</a:t>
+              <a:t>1. Kasper MR, et al. N Engl J Med. 2020.  2. Hu B, et al. Nat Rev Microbiol. 2021.  5. Payne DC, et al. MMWR Morb Mortal Wkly Rep. 2020.</a:t>
             </a:r>
             <a:endParaRPr lang="en-US" sz="1000" dirty="0"/>
           </a:p>
@@ -13498,7 +13700,15 @@
                   <a:schemeClr val="bg1"/>
                 </a:solidFill>
               </a:rPr>
-              <a:t>Asymptomatic and presymptomatic sailors drove rapid person-to-person respiratory spread, made worse by crowded, enclosed living and working spaces.</a:t>
+              <a:t>Close-quarters conditions and asymptomatic and presymptomatic sailors facilitated rapid person-to-person spread.</a:t>
+            </a:r>
+            <a:r>
+              <a:rPr lang="en-US" sz="1600" baseline="30000" dirty="0">
+                <a:solidFill>
+                  <a:schemeClr val="bg1"/>
+                </a:solidFill>
+              </a:rPr>
+              <a:t>1</a:t>
             </a:r>
             <a:endParaRPr lang="en-US" sz="1600" dirty="0"/>
           </a:p>
@@ -13600,6 +13810,14 @@
                 </a:solidFill>
               </a:rPr>
               <a:t>Source of introduction not determined (port visit or COD flights)</a:t>
+            </a:r>
+            <a:r>
+              <a:rPr lang="en-US" sz="1400" baseline="30000" dirty="0">
+                <a:solidFill>
+                  <a:schemeClr val="tx1"/>
+                </a:solidFill>
+              </a:rPr>
+              <a:t>1</a:t>
             </a:r>
             <a:endParaRPr lang="en-US" sz="1500" dirty="0"/>
           </a:p>
@@ -13738,9 +13956,6 @@
               </a:rPr>
               <a:t>Strength: </a:t>
             </a:r>
-            <a:pPr indent="0" marL="0">
-              <a:buNone/>
-            </a:pPr>
             <a:r>
               <a:rPr lang="en-US" sz="1400" dirty="0">
                 <a:solidFill>
@@ -13829,16 +14044,21 @@
               </a:rPr>
               <a:t>Consistency: </a:t>
             </a:r>
-            <a:pPr indent="0" marL="0">
-              <a:buNone/>
-            </a:pPr>
             <a:r>
               <a:rPr lang="en-US" sz="1400" dirty="0">
                 <a:solidFill>
                   <a:schemeClr val="tx1"/>
                 </a:solidFill>
               </a:rPr>
-              <a:t>CDC serosurvey of crew volunteers found the same confined-space pattern</a:t>
+              <a:t>Navy–CDC serosurvey (n = 382) linked infection to shared berthing (OR 3.3) and close contact</a:t>
+            </a:r>
+            <a:r>
+              <a:rPr lang="en-US" sz="1400" baseline="30000" dirty="0">
+                <a:solidFill>
+                  <a:schemeClr val="tx1"/>
+                </a:solidFill>
+              </a:rPr>
+              <a:t>5</a:t>
             </a:r>
             <a:endParaRPr lang="en-US" sz="1400" dirty="0"/>
           </a:p>
@@ -13920,16 +14140,21 @@
               </a:rPr>
               <a:t>Plausibility: </a:t>
             </a:r>
-            <a:pPr indent="0" marL="0">
-              <a:buNone/>
-            </a:pPr>
             <a:r>
               <a:rPr lang="en-US" sz="1400" dirty="0">
                 <a:solidFill>
                   <a:schemeClr val="tx1"/>
                 </a:solidFill>
               </a:rPr>
-              <a:t>Aerosol spread in poorly ventilated spaces fits the biology</a:t>
+              <a:t>Aerosols can linger in indoor air and be inhaled by others</a:t>
+            </a:r>
+            <a:r>
+              <a:rPr lang="en-US" sz="1400" baseline="30000" dirty="0">
+                <a:solidFill>
+                  <a:schemeClr val="tx1"/>
+                </a:solidFill>
+              </a:rPr>
+              <a:t>2</a:t>
             </a:r>
             <a:endParaRPr lang="en-US" sz="1400" dirty="0"/>
           </a:p>
@@ -13950,7 +14175,7 @@
             <a:avLst/>
           </a:prstGeom>
           <a:solidFill>
-            <a:schemeClr val="accent1"/>
+            <a:schemeClr val="accent2"/>
           </a:solidFill>
           <a:ln/>
         </p:spPr>
@@ -14011,16 +14236,13 @@
               </a:rPr>
               <a:t>Biological gradient: </a:t>
             </a:r>
-            <a:pPr indent="0" marL="0">
-              <a:buNone/>
-            </a:pPr>
             <a:r>
               <a:rPr lang="en-US" sz="1400" dirty="0">
                 <a:solidFill>
                   <a:schemeClr val="tx1"/>
                 </a:solidFill>
               </a:rPr>
-              <a:t>Deck &lt; Air &lt; confined departments</a:t>
+              <a:t>Not assessable: confinement was recorded only as confined vs mixed, not graded</a:t>
             </a:r>
             <a:endParaRPr lang="en-US" sz="1400" dirty="0"/>
           </a:p>
@@ -14102,9 +14324,6 @@
               </a:rPr>
               <a:t>Confounding: </a:t>
             </a:r>
-            <a:pPr indent="0" marL="0">
-              <a:buNone/>
-            </a:pPr>
             <a:r>
               <a:rPr lang="en-US" sz="1400" dirty="0">
                 <a:solidFill>
@@ -14193,9 +14412,6 @@
               </a:rPr>
               <a:t>Multiple tests: </a:t>
             </a:r>
-            <a:pPr indent="0" marL="0">
-              <a:buNone/>
-            </a:pPr>
             <a:r>
               <a:rPr lang="en-US" sz="1400" dirty="0">
                 <a:solidFill>
@@ -14351,7 +14567,7 @@
                   <a:schemeClr val="accent6"/>
                 </a:solidFill>
               </a:rPr>
-              <a:t>Kasper MR, et al. N Engl J Med. 2020 (Discussion) and student critical analysis.</a:t>
+              <a:t>1. Kasper MR, Geibe JR, Sears CL, et al. N Engl J Med. 2020;383(25):2417-2426. 'My critical analysis' items are the student's own.</a:t>
             </a:r>
             <a:endParaRPr lang="en-US" sz="1000" dirty="0"/>
           </a:p>
@@ -14498,9 +14714,6 @@
               </a:rPr>
               <a:t>Complete case ascertainment: </a:t>
             </a:r>
-            <a:pPr indent="0" marL="0">
-              <a:buNone/>
-            </a:pPr>
             <a:r>
               <a:rPr lang="en-US" sz="1350" dirty="0">
                 <a:solidFill>
@@ -14527,9 +14740,6 @@
               </a:rPr>
               <a:t>10-week follow-up of all crew: </a:t>
             </a:r>
-            <a:pPr indent="0" marL="0">
-              <a:buNone/>
-            </a:pPr>
             <a:r>
               <a:rPr lang="en-US" sz="1350" dirty="0">
                 <a:solidFill>
@@ -14556,9 +14766,6 @@
               </a:rPr>
               <a:t>Lab confirmation: </a:t>
             </a:r>
-            <a:pPr indent="0" marL="0">
-              <a:buNone/>
-            </a:pPr>
             <a:r>
               <a:rPr lang="en-US" sz="1350" dirty="0">
                 <a:solidFill>
@@ -14585,9 +14792,6 @@
               </a:rPr>
               <a:t>Linked records: </a:t>
             </a:r>
-            <a:pPr indent="0" marL="0">
-              <a:buNone/>
-            </a:pPr>
             <a:r>
               <a:rPr lang="en-US" sz="1350" dirty="0">
                 <a:solidFill>
@@ -14612,18 +14816,23 @@
                   <a:schemeClr val="tx1"/>
                 </a:solidFill>
               </a:rPr>
-              <a:t>Rapid control: </a:t>
-            </a:r>
-            <a:pPr indent="0" marL="0">
-              <a:buNone/>
-            </a:pPr>
+              <a:t>Rapid response: </a:t>
+            </a:r>
             <a:r>
               <a:rPr lang="en-US" sz="1350" dirty="0">
                 <a:solidFill>
                   <a:schemeClr val="tx1"/>
                 </a:solidFill>
               </a:rPr>
-              <a:t>ship in port 4 days after detection; single-room quarantine</a:t>
+              <a:t>ship reached Guam 4 days after the first positive test; single-room quarantine</a:t>
+            </a:r>
+            <a:r>
+              <a:rPr lang="en-US" sz="1350" baseline="30000" dirty="0">
+                <a:solidFill>
+                  <a:schemeClr val="tx1"/>
+                </a:solidFill>
+              </a:rPr>
+              <a:t>1</a:t>
             </a:r>
             <a:endParaRPr lang="en-US" sz="1500" dirty="0"/>
           </a:p>
@@ -14766,6 +14975,14 @@
               </a:rPr>
               <a:t>Identified by authors</a:t>
             </a:r>
+            <a:r>
+              <a:rPr lang="en-US" sz="1300" b="1" baseline="30000" dirty="0">
+                <a:solidFill>
+                  <a:schemeClr val="accent6"/>
+                </a:solidFill>
+              </a:rPr>
+              <a:t>1</a:t>
+            </a:r>
             <a:endParaRPr lang="en-US" sz="1500" dirty="0"/>
           </a:p>
           <a:p>
@@ -14925,7 +15142,15 @@
                   <a:schemeClr val="tx1"/>
                 </a:solidFill>
               </a:rPr>
-              <a:t>Inconsistent subtype denominators in Figure 1</a:t>
+              <a:t>Results text mixes denominators: 43.0% asymptomatic is 572/1,331, described as a share of 1,271</a:t>
+            </a:r>
+            <a:r>
+              <a:rPr lang="en-US" sz="1350" baseline="30000" dirty="0">
+                <a:solidFill>
+                  <a:schemeClr val="tx1"/>
+                </a:solidFill>
+              </a:rPr>
+              <a:t>1</a:t>
             </a:r>
             <a:endParaRPr lang="en-US" sz="1500" dirty="0"/>
           </a:p>
@@ -15074,7 +15299,7 @@
                   <a:schemeClr val="accent6"/>
                 </a:solidFill>
               </a:rPr>
-              <a:t>Student recommendations based on findings; Navy measures from Kasper MR, et al. N Engl J Med. 2020.</a:t>
+              <a:t>1. Kasper MR, Geibe JR, Sears CL, et al. N Engl J Med. 2020;383(25):2417-2426. Recommendations are the student's own.</a:t>
             </a:r>
             <a:endParaRPr lang="en-US" sz="1000" dirty="0"/>
           </a:p>
@@ -15178,7 +15403,7 @@
               </a:rPr>
               <a:t>Immediate control</a:t>
             </a:r>
-            <a:endParaRPr lang="en-US" sz="1500" dirty="0"/>
+            <a:endParaRPr lang="en-US" sz="1350" dirty="0"/>
           </a:p>
           <a:p>
             <a:pPr indent="0" marL="0">
@@ -15190,9 +15415,25 @@
                   <a:schemeClr val="tx1"/>
                 </a:solidFill>
               </a:rPr>
-              <a:t>Test everyone, not just symptomatic people, because 77% of cases had no symptoms when they tested positive; isolate off-ship in single rooms</a:t>
-            </a:r>
-            <a:endParaRPr lang="en-US" sz="1500" dirty="0"/>
+              <a:t>Test everyone, not just symptomatic people, because 77% of cases had no symptoms when they tested positive</a:t>
+            </a:r>
+            <a:r>
+              <a:rPr lang="en-US" sz="1350" baseline="30000" dirty="0">
+                <a:solidFill>
+                  <a:schemeClr val="tx1"/>
+                </a:solidFill>
+              </a:rPr>
+              <a:t>1</a:t>
+            </a:r>
+            <a:r>
+              <a:rPr lang="en-US" sz="1350" dirty="0">
+                <a:solidFill>
+                  <a:schemeClr val="tx1"/>
+                </a:solidFill>
+              </a:rPr>
+              <a:t>; isolate off-ship in single rooms</a:t>
+            </a:r>
+            <a:endParaRPr lang="en-US" sz="1350" dirty="0"/>
           </a:p>
         </p:txBody>
       </p:sp>
@@ -15294,7 +15535,7 @@
               </a:rPr>
               <a:t>Prevention</a:t>
             </a:r>
-            <a:endParaRPr lang="en-US" sz="1500" dirty="0"/>
+            <a:endParaRPr lang="en-US" sz="1350" dirty="0"/>
           </a:p>
           <a:p>
             <a:pPr indent="0" marL="0">
@@ -15306,9 +15547,25 @@
                   <a:schemeClr val="tx1"/>
                 </a:solidFill>
               </a:rPr>
-              <a:t>14-day restriction of movement plus PCR before deployment; masks, small cohorts and better ventilation in confined departments (RR 2.6)</a:t>
-            </a:r>
-            <a:endParaRPr lang="en-US" sz="1500" dirty="0"/>
+              <a:t>14-day restriction of movement plus PCR before deployment (Navy policy</a:t>
+            </a:r>
+            <a:r>
+              <a:rPr lang="en-US" sz="1350" baseline="30000" dirty="0">
+                <a:solidFill>
+                  <a:schemeClr val="tx1"/>
+                </a:solidFill>
+              </a:rPr>
+              <a:t>1</a:t>
+            </a:r>
+            <a:r>
+              <a:rPr lang="en-US" sz="1350" dirty="0">
+                <a:solidFill>
+                  <a:schemeClr val="tx1"/>
+                </a:solidFill>
+              </a:rPr>
+              <a:t>); masks, small cohorts and better ventilation in confined departments (RR 2.6)</a:t>
+            </a:r>
+            <a:endParaRPr lang="en-US" sz="1350" dirty="0"/>
           </a:p>
         </p:txBody>
       </p:sp>
@@ -15410,7 +15667,7 @@
               </a:rPr>
               <a:t>Surveillance</a:t>
             </a:r>
-            <a:endParaRPr lang="en-US" sz="1500" dirty="0"/>
+            <a:endParaRPr lang="en-US" sz="1350" dirty="0"/>
           </a:p>
           <a:p>
             <a:pPr indent="0" marL="0">
@@ -15422,9 +15679,17 @@
                   <a:schemeClr val="tx1"/>
                 </a:solidFill>
               </a:rPr>
-              <a:t>Routine PCR or pooled screening at sea; do not rely on temperature checks, since fever was present in only 13%</a:t>
-            </a:r>
-            <a:endParaRPr lang="en-US" sz="1500" dirty="0"/>
+              <a:t>Routine PCR or pooled screening at sea; do not rely on temperature checks, since only 13% of symptomatic cases reported fever</a:t>
+            </a:r>
+            <a:r>
+              <a:rPr lang="en-US" sz="1350" baseline="30000" dirty="0">
+                <a:solidFill>
+                  <a:schemeClr val="tx1"/>
+                </a:solidFill>
+              </a:rPr>
+              <a:t>1</a:t>
+            </a:r>
+            <a:endParaRPr lang="en-US" sz="1350" dirty="0"/>
           </a:p>
         </p:txBody>
       </p:sp>
@@ -15526,7 +15791,7 @@
               </a:rPr>
               <a:t>Communication</a:t>
             </a:r>
-            <a:endParaRPr lang="en-US" sz="1500" dirty="0"/>
+            <a:endParaRPr lang="en-US" sz="1350" dirty="0"/>
           </a:p>
           <a:p>
             <a:pPr indent="0" marL="0">
@@ -15538,9 +15803,17 @@
                   <a:schemeClr val="tx1"/>
                 </a:solidFill>
               </a:rPr>
-              <a:t>Tell crews that feeling well does not mean uninfected; brief medical staff on atypical symptoms such as loss of smell and headache</a:t>
-            </a:r>
-            <a:endParaRPr lang="en-US" sz="1500" dirty="0"/>
+              <a:t>Tell crews that feeling well does not mean uninfected; brief medical staff on common symptoms such as headache and altered taste or smell</a:t>
+            </a:r>
+            <a:r>
+              <a:rPr lang="en-US" sz="1350" baseline="30000" dirty="0">
+                <a:solidFill>
+                  <a:schemeClr val="tx1"/>
+                </a:solidFill>
+              </a:rPr>
+              <a:t>1</a:t>
+            </a:r>
+            <a:endParaRPr lang="en-US" sz="1350" dirty="0"/>
           </a:p>
         </p:txBody>
       </p:sp>
@@ -15642,7 +15915,7 @@
               </a:rPr>
               <a:t>Future investigations</a:t>
             </a:r>
-            <a:endParaRPr lang="en-US" sz="1500" dirty="0"/>
+            <a:endParaRPr lang="en-US" sz="1350" dirty="0"/>
           </a:p>
           <a:p>
             <a:pPr indent="0" marL="0">
@@ -15656,7 +15929,7 @@
               </a:rPr>
               <a:t>Sequence isolates to trace introductions and chains; assess ventilation; fit adjusted models and report RRs for cohort data</a:t>
             </a:r>
-            <a:endParaRPr lang="en-US" sz="1500" dirty="0"/>
+            <a:endParaRPr lang="en-US" sz="1350" dirty="0"/>
           </a:p>
         </p:txBody>
       </p:sp>
@@ -15714,9 +15987,6 @@
               </a:rPr>
               <a:t>Evidence it works: </a:t>
             </a:r>
-            <a:pPr indent="0" marL="0">
-              <a:buNone/>
-            </a:pPr>
             <a:r>
               <a:rPr lang="en-US" sz="1400" dirty="0">
                 <a:solidFill>
@@ -15724,6 +15994,14 @@
                 </a:solidFill>
               </a:rPr>
               <a:t>after the Navy adopted pre-deployment quarantine, testing and reduced port visits, it deployed multiple ships without another serious outbreak.</a:t>
+            </a:r>
+            <a:r>
+              <a:rPr lang="en-US" sz="1400" baseline="30000" dirty="0">
+                <a:solidFill>
+                  <a:schemeClr val="bg1"/>
+                </a:solidFill>
+              </a:rPr>
+              <a:t>1</a:t>
             </a:r>
             <a:endParaRPr lang="en-US" sz="1400" dirty="0"/>
           </a:p>
@@ -15872,7 +16150,7 @@
                   <a:schemeClr val="accent6"/>
                 </a:solidFill>
               </a:rPr>
-              <a:t>Source: Kasper MR, et al. N Engl J Med. 2020;383:2417-2426.</a:t>
+              <a:t>1. Kasper MR, Geibe JR, Sears CL, et al. N Engl J Med. 2020;383(25):2417-2426.</a:t>
             </a:r>
             <a:endParaRPr lang="en-US" sz="1000" dirty="0"/>
           </a:p>
@@ -16015,6 +16293,14 @@
               </a:rPr>
               <a:t>crew members aboard (the population at risk)</a:t>
             </a:r>
+            <a:r>
+              <a:rPr lang="en-US" sz="1500" baseline="30000" dirty="0">
+                <a:solidFill>
+                  <a:schemeClr val="tx1"/>
+                </a:solidFill>
+              </a:rPr>
+              <a:t>1</a:t>
+            </a:r>
             <a:endParaRPr lang="en-US" sz="1500" dirty="0"/>
           </a:p>
         </p:txBody>
@@ -16156,6 +16442,14 @@
               </a:rPr>
               <a:t>laboratory-confirmed cases (26.6% of crew)</a:t>
             </a:r>
+            <a:r>
+              <a:rPr lang="en-US" sz="1500" baseline="30000" dirty="0">
+                <a:solidFill>
+                  <a:schemeClr val="tx1"/>
+                </a:solidFill>
+              </a:rPr>
+              <a:t>1</a:t>
+            </a:r>
             <a:endParaRPr lang="en-US" sz="1500" dirty="0"/>
           </a:p>
         </p:txBody>
@@ -16297,6 +16591,14 @@
               </a:rPr>
               <a:t>suspected cases (clinical criteria, no positive test)</a:t>
             </a:r>
+            <a:r>
+              <a:rPr lang="en-US" sz="1500" baseline="30000" dirty="0">
+                <a:solidFill>
+                  <a:schemeClr val="tx1"/>
+                </a:solidFill>
+              </a:rPr>
+              <a:t>1</a:t>
+            </a:r>
             <a:endParaRPr lang="en-US" sz="1500" dirty="0"/>
           </a:p>
         </p:txBody>
@@ -16438,6 +16740,14 @@
               </a:rPr>
               <a:t>hospitalized (1.7% of 1,331 confirmed + suspected)</a:t>
             </a:r>
+            <a:r>
+              <a:rPr lang="en-US" sz="1500" baseline="30000" dirty="0">
+                <a:solidFill>
+                  <a:schemeClr val="tx1"/>
+                </a:solidFill>
+              </a:rPr>
+              <a:t>1</a:t>
+            </a:r>
             <a:endParaRPr lang="en-US" sz="1500" dirty="0"/>
           </a:p>
         </p:txBody>
@@ -16579,6 +16889,14 @@
               </a:rPr>
               <a:t>admitted to intensive care (0.3%)</a:t>
             </a:r>
+            <a:r>
+              <a:rPr lang="en-US" sz="1500" baseline="30000" dirty="0">
+                <a:solidFill>
+                  <a:schemeClr val="tx1"/>
+                </a:solidFill>
+              </a:rPr>
+              <a:t>1</a:t>
+            </a:r>
             <a:endParaRPr lang="en-US" sz="1500" dirty="0"/>
           </a:p>
         </p:txBody>
@@ -16719,6 +17037,14 @@
                 </a:solidFill>
               </a:rPr>
               <a:t>death from Covid-19–related cardiovascular complications</a:t>
+            </a:r>
+            <a:r>
+              <a:rPr lang="en-US" sz="1500" baseline="30000" dirty="0">
+                <a:solidFill>
+                  <a:schemeClr val="tx1"/>
+                </a:solidFill>
+              </a:rPr>
+              <a:t>1</a:t>
             </a:r>
             <a:endParaRPr lang="en-US" sz="1500" dirty="0"/>
           </a:p>
@@ -16901,6 +17227,14 @@
               </a:rPr>
               <a:t>SARS-CoV-2 infected 27% of a 4,779-person carrier crew in 8 weeks</a:t>
             </a:r>
+            <a:r>
+              <a:rPr lang="en-US" sz="1700" baseline="30000" dirty="0">
+                <a:solidFill>
+                  <a:schemeClr val="bg1"/>
+                </a:solidFill>
+              </a:rPr>
+              <a:t>1</a:t>
+            </a:r>
             <a:endParaRPr lang="en-US" sz="1700" dirty="0"/>
           </a:p>
         </p:txBody>
@@ -17189,13 +17523,57 @@
               </a:rPr>
               <a:t>77% had no symptoms when they tested positive; 45% never had symptoms</a:t>
             </a:r>
+            <a:r>
+              <a:rPr lang="en-US" sz="1700" baseline="30000" dirty="0">
+                <a:solidFill>
+                  <a:schemeClr val="bg1"/>
+                </a:solidFill>
+              </a:rPr>
+              <a:t>1</a:t>
+            </a:r>
             <a:endParaRPr lang="en-US" sz="1700" dirty="0"/>
           </a:p>
         </p:txBody>
       </p:sp>
       <p:sp>
         <p:nvSpPr>
-          <p:cNvPr id="13" name="lesson panel"/>
+          <p:cNvPr id="13" name="Text 11"/>
+          <p:cNvSpPr txBox="1"/>
+          <p:nvPr/>
+        </p:nvSpPr>
+        <p:spPr>
+          <a:xfrm>
+            <a:off x="731520" y="6355080"/>
+            <a:ext cx="10058400" cy="320040"/>
+          </a:xfrm>
+          <a:prstGeom prst="rect">
+            <a:avLst/>
+          </a:prstGeom>
+          <a:noFill/>
+          <a:ln/>
+        </p:spPr>
+        <p:txBody>
+          <a:bodyPr wrap="square" lIns="0" tIns="0" rIns="0" bIns="0" rtlCol="0" anchor="ctr"/>
+          <a:lstStyle/>
+          <a:p>
+            <a:pPr indent="0" marL="0">
+              <a:buNone/>
+            </a:pPr>
+            <a:r>
+              <a:rPr lang="en-US" sz="1000" i="1" dirty="0">
+                <a:solidFill>
+                  <a:schemeClr val="accent3"/>
+                </a:solidFill>
+              </a:rPr>
+              <a:t>1. Kasper MR, Geibe JR, Sears CL, et al. N Engl J Med. 2020;383(25):2417-2426.</a:t>
+            </a:r>
+            <a:endParaRPr lang="en-US" sz="1000" dirty="0"/>
+          </a:p>
+        </p:txBody>
+      </p:sp>
+      <p:sp>
+        <p:nvSpPr>
+          <p:cNvPr id="14" name="lesson panel"/>
           <p:cNvSpPr/>
           <p:nvPr/>
         </p:nvSpPr>
@@ -17217,7 +17595,7 @@
       </p:sp>
       <p:sp>
         <p:nvSpPr>
-          <p:cNvPr id="14" name="Text 12"/>
+          <p:cNvPr id="15" name="Text 13"/>
           <p:cNvSpPr txBox="1"/>
           <p:nvPr/>
         </p:nvSpPr>
@@ -17247,9 +17625,6 @@
               </a:rPr>
               <a:t>Lesson for public health: </a:t>
             </a:r>
-            <a:pPr indent="0" marL="0">
-              <a:buNone/>
-            </a:pPr>
             <a:r>
               <a:rPr lang="en-US" sz="1700" dirty="0">
                 <a:solidFill>
@@ -17264,7 +17639,7 @@
       </p:sp>
       <p:sp>
         <p:nvSpPr>
-          <p:cNvPr id="16" name="Text 0"/>
+          <p:cNvPr id="17" name="Text 0"/>
           <p:cNvSpPr/>
           <p:nvPr>
             <p:ph idx="100" type="title" hasCustomPrompt="1"/>
@@ -17294,7 +17669,7 @@
       </p:sp>
       <p:sp>
         <p:nvSpPr>
-          <p:cNvPr id="17" name="Text 0"/>
+          <p:cNvPr id="18" name="Text 0"/>
           <p:cNvSpPr/>
           <p:nvPr>
             <p:ph idx="101" type="body" hasCustomPrompt="1"/>
@@ -17423,7 +17798,23 @@
                   <a:schemeClr val="tx1"/>
                 </a:solidFill>
               </a:rPr>
-              <a:t>Kasper MR, Geibe JR, Sears CL, et al. An outbreak of Covid-19 on an aircraft carrier. N Engl J Med. 2020;383(25):2417-2426. doi:10.1056/NEJMoa2019375</a:t>
+              <a:t>Kasper MR, Geibe JR, Sears CL, et al. An outbreak of Covid-19 on an aircraft carrier. </a:t>
+            </a:r>
+            <a:r>
+              <a:rPr lang="en-US" sz="1500" i="1" dirty="0">
+                <a:solidFill>
+                  <a:schemeClr val="tx1"/>
+                </a:solidFill>
+              </a:rPr>
+              <a:t>N Engl J Med</a:t>
+            </a:r>
+            <a:r>
+              <a:rPr lang="en-US" sz="1500" dirty="0">
+                <a:solidFill>
+                  <a:schemeClr val="tx1"/>
+                </a:solidFill>
+              </a:rPr>
+              <a:t>. 2020;383(25):2417-2426. doi:10.1056/NEJMoa2019375</a:t>
             </a:r>
             <a:endParaRPr lang="en-US" sz="1500" dirty="0"/>
           </a:p>
@@ -17442,7 +17833,23 @@
                   <a:schemeClr val="tx1"/>
                 </a:solidFill>
               </a:rPr>
-              <a:t>Hu B, Guo H, Zhou P, Shi ZL. Characteristics of SARS-CoV-2 and COVID-19. Nat Rev Microbiol. 2021;19(3):141-154. doi:10.1038/s41579-020-00459-7</a:t>
+              <a:t>Hu B, Guo H, Zhou P, Shi ZL. Characteristics of SARS-CoV-2 and COVID-19. </a:t>
+            </a:r>
+            <a:r>
+              <a:rPr lang="en-US" sz="1500" i="1" dirty="0">
+                <a:solidFill>
+                  <a:schemeClr val="tx1"/>
+                </a:solidFill>
+              </a:rPr>
+              <a:t>Nat Rev Microbiol</a:t>
+            </a:r>
+            <a:r>
+              <a:rPr lang="en-US" sz="1500" dirty="0">
+                <a:solidFill>
+                  <a:schemeClr val="tx1"/>
+                </a:solidFill>
+              </a:rPr>
+              <a:t>. 2021;19(3):141-154. doi:10.1038/s41579-020-00459-7</a:t>
             </a:r>
             <a:endParaRPr lang="en-US" sz="1500" dirty="0"/>
           </a:p>
@@ -17461,7 +17868,23 @@
                   <a:schemeClr val="tx1"/>
                 </a:solidFill>
               </a:rPr>
-              <a:t>Lauer SA, Grantz KH, Bi Q, et al. The incubation period of coronavirus disease 2019 (COVID-19) from publicly reported confirmed cases: estimation and application. Ann Intern Med. 2020;172(9):577-582. doi:10.7326/M20-0504</a:t>
+              <a:t>Lauer SA, Grantz KH, Bi Q, et al. The incubation period of coronavirus disease 2019 (COVID-19) from publicly reported confirmed cases: estimation and application. </a:t>
+            </a:r>
+            <a:r>
+              <a:rPr lang="en-US" sz="1500" i="1" dirty="0">
+                <a:solidFill>
+                  <a:schemeClr val="tx1"/>
+                </a:solidFill>
+              </a:rPr>
+              <a:t>Ann Intern Med</a:t>
+            </a:r>
+            <a:r>
+              <a:rPr lang="en-US" sz="1500" dirty="0">
+                <a:solidFill>
+                  <a:schemeClr val="tx1"/>
+                </a:solidFill>
+              </a:rPr>
+              <a:t>. 2020;172(9):577-582. doi:10.7326/M20-0504</a:t>
             </a:r>
             <a:endParaRPr lang="en-US" sz="1500" dirty="0"/>
           </a:p>
@@ -17480,7 +17903,39 @@
                   <a:schemeClr val="tx1"/>
                 </a:solidFill>
               </a:rPr>
-              <a:t>He X, Lau EHY, Wu P, et al. Temporal dynamics in viral shedding and transmissibility of COVID-19. Nat Med. 2020;26(5):672-675. doi:10.1038/s41591-020-0869-5</a:t>
+              <a:t>He X, Lau EHY, Wu P, et al. Temporal dynamics in viral shedding and transmissibility of COVID-19. </a:t>
+            </a:r>
+            <a:r>
+              <a:rPr lang="en-US" sz="1500" i="1" dirty="0">
+                <a:solidFill>
+                  <a:schemeClr val="tx1"/>
+                </a:solidFill>
+              </a:rPr>
+              <a:t>Nat Med</a:t>
+            </a:r>
+            <a:r>
+              <a:rPr lang="en-US" sz="1500" dirty="0">
+                <a:solidFill>
+                  <a:schemeClr val="tx1"/>
+                </a:solidFill>
+              </a:rPr>
+              <a:t>. 2020;26(5):672-675. doi:10.1038/s41591-020-0869-5. Published correction appears in </a:t>
+            </a:r>
+            <a:r>
+              <a:rPr lang="en-US" sz="1500" i="1" dirty="0">
+                <a:solidFill>
+                  <a:schemeClr val="tx1"/>
+                </a:solidFill>
+              </a:rPr>
+              <a:t>Nat Med</a:t>
+            </a:r>
+            <a:r>
+              <a:rPr lang="en-US" sz="1500" dirty="0">
+                <a:solidFill>
+                  <a:schemeClr val="tx1"/>
+                </a:solidFill>
+              </a:rPr>
+              <a:t>. 2020;26(9):1491-1493.</a:t>
             </a:r>
             <a:endParaRPr lang="en-US" sz="1500" dirty="0"/>
           </a:p>
@@ -17499,7 +17954,23 @@
                   <a:schemeClr val="tx1"/>
                 </a:solidFill>
               </a:rPr>
-              <a:t>Payne DC, Smith-Jeffcoat SE, Nowak G, et al. SARS-CoV-2 infections and serologic responses from a sample of U.S. Navy service members — USS Theodore Roosevelt, April 2020. MMWR Morb Mortal Wkly Rep. 2020;69(23):714-721. doi:10.15585/mmwr.mm6923e4</a:t>
+              <a:t>Payne DC, Smith-Jeffcoat SE, Nowak G, et al. SARS-CoV-2 infections and serologic responses from a sample of U.S. Navy service members — USS Theodore Roosevelt, April 2020. </a:t>
+            </a:r>
+            <a:r>
+              <a:rPr lang="en-US" sz="1500" i="1" dirty="0">
+                <a:solidFill>
+                  <a:schemeClr val="tx1"/>
+                </a:solidFill>
+              </a:rPr>
+              <a:t>MMWR Morb Mortal Wkly Rep</a:t>
+            </a:r>
+            <a:r>
+              <a:rPr lang="en-US" sz="1500" dirty="0">
+                <a:solidFill>
+                  <a:schemeClr val="tx1"/>
+                </a:solidFill>
+              </a:rPr>
+              <a:t>. 2020;69(23):714-721. doi:10.15585/mmwr.mm6923e4</a:t>
             </a:r>
             <a:endParaRPr lang="en-US" sz="1500" dirty="0"/>
           </a:p>
@@ -17678,7 +18149,7 @@
                   <a:schemeClr val="accent6"/>
                 </a:solidFill>
               </a:rPr>
-              <a:t>Source: Kasper MR, et al. N Engl J Med. 2020;383:2417-2426.</a:t>
+              <a:t>1. Kasper MR, Geibe JR, Sears CL, et al. N Engl J Med. 2020;383(25):2417-2426.</a:t>
             </a:r>
             <a:endParaRPr lang="en-US" sz="1000" dirty="0"/>
           </a:p>
@@ -17774,6 +18245,14 @@
               </a:rPr>
               <a:t>Nuclear-powered carrier on Western Pacific operations; diverted to U.S. Naval Base Guam (42-bed naval hospital)</a:t>
             </a:r>
+            <a:r>
+              <a:rPr lang="en-US" sz="1500" baseline="30000" dirty="0">
+                <a:solidFill>
+                  <a:schemeClr val="tx1"/>
+                </a:solidFill>
+              </a:rPr>
+              <a:t>1</a:t>
+            </a:r>
             <a:endParaRPr lang="en-US" sz="1500" dirty="0"/>
           </a:p>
         </p:txBody>
@@ -17868,6 +18347,14 @@
               </a:rPr>
               <a:t>Enlisted crew sleep in open bays of tightly spaced bunks and gather in galleys and gyms</a:t>
             </a:r>
+            <a:r>
+              <a:rPr lang="en-US" sz="1500" baseline="30000" dirty="0">
+                <a:solidFill>
+                  <a:schemeClr val="tx1"/>
+                </a:solidFill>
+              </a:rPr>
+              <a:t>1</a:t>
+            </a:r>
             <a:endParaRPr lang="en-US" sz="1500" dirty="0"/>
           </a:p>
         </p:txBody>
@@ -17960,7 +18447,15 @@
                   <a:schemeClr val="tx1"/>
                 </a:solidFill>
               </a:rPr>
-              <a:t>Mean age 27 y, 78% male, ~69% under 30, all fit for sea duty and fully immunized</a:t>
+              <a:t>Mean age 27 y, 78% male, ~69% under 30, fit for sea duty and up to date on routine immunizations</a:t>
+            </a:r>
+            <a:r>
+              <a:rPr lang="en-US" sz="1500" baseline="30000" dirty="0">
+                <a:solidFill>
+                  <a:schemeClr val="tx1"/>
+                </a:solidFill>
+              </a:rPr>
+              <a:t>1</a:t>
             </a:r>
             <a:endParaRPr lang="en-US" sz="1500" dirty="0"/>
           </a:p>
@@ -18056,6 +18551,14 @@
               </a:rPr>
               <a:t>Day 13 at sea: 3 sailors reported symptoms and tested rRT-PCR positive (March 23, 2020)</a:t>
             </a:r>
+            <a:r>
+              <a:rPr lang="en-US" sz="1500" baseline="30000" dirty="0">
+                <a:solidFill>
+                  <a:schemeClr val="tx1"/>
+                </a:solidFill>
+              </a:rPr>
+              <a:t>1</a:t>
+            </a:r>
             <a:endParaRPr lang="en-US" sz="1500" dirty="0"/>
           </a:p>
         </p:txBody>
@@ -18155,7 +18658,15 @@
                   <a:schemeClr val="bg1"/>
                 </a:solidFill>
               </a:rPr>
-              <a:t>One of the first fully enumerated SARS-CoV-2 outbreaks: every crew member was tested and followed for at least 10 weeks</a:t>
+              <a:t>Every crew member was evaluated, tested and followed for at least 10 weeks, a level of documentation hard to achieve in civilian populations</a:t>
+            </a:r>
+            <a:r>
+              <a:rPr lang="en-US" sz="1500" baseline="30000" dirty="0">
+                <a:solidFill>
+                  <a:schemeClr val="bg1"/>
+                </a:solidFill>
+              </a:rPr>
+              <a:t>1</a:t>
             </a:r>
             <a:endParaRPr lang="en-US" sz="1500" dirty="0"/>
           </a:p>
@@ -18173,7 +18684,7 @@
                   <a:schemeClr val="bg1"/>
                 </a:solidFill>
               </a:rPr>
-              <a:t>Gives a known denominator, so attack rates are real, not estimates</a:t>
+              <a:t>Gives a known denominator, so attack rates are not distorted by sampling</a:t>
             </a:r>
             <a:endParaRPr lang="en-US" sz="1500" dirty="0"/>
           </a:p>
@@ -18191,7 +18702,15 @@
                   <a:schemeClr val="bg1"/>
                 </a:solidFill>
               </a:rPr>
-              <a:t>Shows how the virus behaves in young, healthy adults living in close quarters</a:t>
+              <a:t>Shows how SARS-CoV-2 behaves in young, healthy adults housed in close quarters</a:t>
+            </a:r>
+            <a:r>
+              <a:rPr lang="en-US" sz="1500" baseline="30000" dirty="0">
+                <a:solidFill>
+                  <a:schemeClr val="bg1"/>
+                </a:solidFill>
+              </a:rPr>
+              <a:t>1</a:t>
             </a:r>
             <a:endParaRPr lang="en-US" sz="1500" dirty="0"/>
           </a:p>
@@ -18209,7 +18728,15 @@
                   <a:schemeClr val="bg1"/>
                 </a:solidFill>
               </a:rPr>
-              <a:t>Carriers are critical to national security; the outbreak took one out of service</a:t>
+              <a:t>The outbreak pulled a deployed carrier off Western Pacific operations and into port in Guam</a:t>
+            </a:r>
+            <a:r>
+              <a:rPr lang="en-US" sz="1500" baseline="30000" dirty="0">
+                <a:solidFill>
+                  <a:schemeClr val="bg1"/>
+                </a:solidFill>
+              </a:rPr>
+              <a:t>1</a:t>
             </a:r>
             <a:endParaRPr lang="en-US" sz="1500" dirty="0"/>
           </a:p>
@@ -18358,7 +18885,7 @@
                   <a:schemeClr val="accent6"/>
                 </a:solidFill>
               </a:rPr>
-              <a:t>Source: Kasper MR, et al. N Engl J Med. 2020;383:2417-2426.</a:t>
+              <a:t>1. Kasper MR, Geibe JR, Sears CL, et al. N Engl J Med. 2020;383(25):2417-2426.</a:t>
             </a:r>
             <a:endParaRPr lang="en-US" sz="1000" dirty="0"/>
           </a:p>
@@ -18372,8 +18899,8 @@
         </p:nvSpPr>
         <p:spPr>
           <a:xfrm>
-            <a:off x="822960" y="3063240"/>
-            <a:ext cx="10515600" cy="0"/>
+            <a:off x="1280160" y="3063240"/>
+            <a:ext cx="9601200" cy="0"/>
           </a:xfrm>
           <a:prstGeom prst="line">
             <a:avLst/>
@@ -18395,7 +18922,7 @@
         </p:nvSpPr>
         <p:spPr>
           <a:xfrm>
-            <a:off x="667512" y="2907792"/>
+            <a:off x="1124712" y="2907792"/>
             <a:ext cx="310896" cy="310896"/>
           </a:xfrm>
           <a:prstGeom prst="ellipse">
@@ -18420,8 +18947,8 @@
         </p:nvSpPr>
         <p:spPr>
           <a:xfrm>
-            <a:off x="-137160" y="1463040"/>
-            <a:ext cx="1920240" cy="411480"/>
+            <a:off x="411480" y="1463040"/>
+            <a:ext cx="1737360" cy="411480"/>
           </a:xfrm>
           <a:prstGeom prst="rect">
             <a:avLst/>
@@ -18459,8 +18986,8 @@
         </p:nvSpPr>
         <p:spPr>
           <a:xfrm>
-            <a:off x="-137160" y="1874520"/>
-            <a:ext cx="1920240" cy="1005840"/>
+            <a:off x="411480" y="1874520"/>
+            <a:ext cx="1737360" cy="1005840"/>
           </a:xfrm>
           <a:prstGeom prst="rect">
             <a:avLst/>
@@ -18483,6 +19010,14 @@
               </a:rPr>
               <a:t>Port visit during deployment</a:t>
             </a:r>
+            <a:r>
+              <a:rPr lang="en-US" sz="1350" baseline="30000" dirty="0">
+                <a:solidFill>
+                  <a:schemeClr val="tx1"/>
+                </a:solidFill>
+              </a:rPr>
+              <a:t>1</a:t>
+            </a:r>
             <a:endParaRPr lang="en-US" sz="1350" dirty="0"/>
           </a:p>
         </p:txBody>
@@ -18495,7 +19030,7 @@
         </p:nvSpPr>
         <p:spPr>
           <a:xfrm>
-            <a:off x="2770632" y="2907792"/>
+            <a:off x="3044952" y="2907792"/>
             <a:ext cx="310896" cy="310896"/>
           </a:xfrm>
           <a:prstGeom prst="ellipse">
@@ -18520,8 +19055,8 @@
         </p:nvSpPr>
         <p:spPr>
           <a:xfrm>
-            <a:off x="1965960" y="3383280"/>
-            <a:ext cx="1920240" cy="411480"/>
+            <a:off x="2331720" y="3383280"/>
+            <a:ext cx="1737360" cy="411480"/>
           </a:xfrm>
           <a:prstGeom prst="rect">
             <a:avLst/>
@@ -18559,8 +19094,8 @@
         </p:nvSpPr>
         <p:spPr>
           <a:xfrm>
-            <a:off x="1965960" y="3794760"/>
-            <a:ext cx="1920240" cy="1005840"/>
+            <a:off x="2331720" y="3794760"/>
+            <a:ext cx="1737360" cy="1005840"/>
           </a:xfrm>
           <a:prstGeom prst="rect">
             <a:avLst/>
@@ -18581,7 +19116,15 @@
                   <a:schemeClr val="tx1"/>
                 </a:solidFill>
               </a:rPr>
-              <a:t>Earliest symptom onset (found in retrospect); COD flights Mar 11–17</a:t>
+              <a:t>Earliest symptom onset (found in retrospect); COD flights Mar 11–16</a:t>
+            </a:r>
+            <a:r>
+              <a:rPr lang="en-US" sz="1350" baseline="30000" dirty="0">
+                <a:solidFill>
+                  <a:schemeClr val="tx1"/>
+                </a:solidFill>
+              </a:rPr>
+              <a:t>1</a:t>
             </a:r>
             <a:endParaRPr lang="en-US" sz="1350" dirty="0"/>
           </a:p>
@@ -18595,7 +19138,7 @@
         </p:nvSpPr>
         <p:spPr>
           <a:xfrm>
-            <a:off x="4873752" y="2907792"/>
+            <a:off x="4965192" y="2907792"/>
             <a:ext cx="310896" cy="310896"/>
           </a:xfrm>
           <a:prstGeom prst="ellipse">
@@ -18620,8 +19163,8 @@
         </p:nvSpPr>
         <p:spPr>
           <a:xfrm>
-            <a:off x="4069080" y="1463040"/>
-            <a:ext cx="1920240" cy="411480"/>
+            <a:off x="4251960" y="1463040"/>
+            <a:ext cx="1737360" cy="411480"/>
           </a:xfrm>
           <a:prstGeom prst="rect">
             <a:avLst/>
@@ -18659,8 +19202,8 @@
         </p:nvSpPr>
         <p:spPr>
           <a:xfrm>
-            <a:off x="4069080" y="1874520"/>
-            <a:ext cx="1920240" cy="1005840"/>
+            <a:off x="4251960" y="1874520"/>
+            <a:ext cx="1737360" cy="1005840"/>
           </a:xfrm>
           <a:prstGeom prst="rect">
             <a:avLst/>
@@ -18683,6 +19226,14 @@
               </a:rPr>
               <a:t>First 3 positive tests; ~400 close contacts traced within 24 h</a:t>
             </a:r>
+            <a:r>
+              <a:rPr lang="en-US" sz="1350" baseline="30000" dirty="0">
+                <a:solidFill>
+                  <a:schemeClr val="tx1"/>
+                </a:solidFill>
+              </a:rPr>
+              <a:t>1</a:t>
+            </a:r>
             <a:endParaRPr lang="en-US" sz="1350" dirty="0"/>
           </a:p>
         </p:txBody>
@@ -18695,7 +19246,7 @@
         </p:nvSpPr>
         <p:spPr>
           <a:xfrm>
-            <a:off x="6976872" y="2907792"/>
+            <a:off x="6885432" y="2907792"/>
             <a:ext cx="310896" cy="310896"/>
           </a:xfrm>
           <a:prstGeom prst="ellipse">
@@ -18721,7 +19272,7 @@
         <p:spPr>
           <a:xfrm>
             <a:off x="6172200" y="3383280"/>
-            <a:ext cx="1920240" cy="411480"/>
+            <a:ext cx="1737360" cy="411480"/>
           </a:xfrm>
           <a:prstGeom prst="rect">
             <a:avLst/>
@@ -18760,7 +19311,7 @@
         <p:spPr>
           <a:xfrm>
             <a:off x="6172200" y="3794760"/>
-            <a:ext cx="1920240" cy="1005840"/>
+            <a:ext cx="1737360" cy="1005840"/>
           </a:xfrm>
           <a:prstGeom prst="rect">
             <a:avLst/>
@@ -18783,6 +19334,14 @@
               </a:rPr>
               <a:t>Ship docks in Guam; isolation and quarantine ashore begin</a:t>
             </a:r>
+            <a:r>
+              <a:rPr lang="en-US" sz="1350" baseline="30000" dirty="0">
+                <a:solidFill>
+                  <a:schemeClr val="tx1"/>
+                </a:solidFill>
+              </a:rPr>
+              <a:t>1</a:t>
+            </a:r>
             <a:endParaRPr lang="en-US" sz="1350" dirty="0"/>
           </a:p>
         </p:txBody>
@@ -18795,7 +19354,7 @@
         </p:nvSpPr>
         <p:spPr>
           <a:xfrm>
-            <a:off x="9079992" y="2907792"/>
+            <a:off x="8805672" y="2907792"/>
             <a:ext cx="310896" cy="310896"/>
           </a:xfrm>
           <a:prstGeom prst="ellipse">
@@ -18820,8 +19379,8 @@
         </p:nvSpPr>
         <p:spPr>
           <a:xfrm>
-            <a:off x="8275320" y="1463040"/>
-            <a:ext cx="1920240" cy="411480"/>
+            <a:off x="8092440" y="1463040"/>
+            <a:ext cx="1737360" cy="411480"/>
           </a:xfrm>
           <a:prstGeom prst="rect">
             <a:avLst/>
@@ -18845,7 +19404,7 @@
                 <a:ea typeface="Cambria" pitchFamily="34" charset="-122"/>
                 <a:cs typeface="Cambria" pitchFamily="34" charset="-120"/>
               </a:rPr>
-              <a:t>Apr</a:t>
+              <a:t>Ashore</a:t>
             </a:r>
             <a:endParaRPr lang="en-US" sz="1800" dirty="0"/>
           </a:p>
@@ -18859,8 +19418,8 @@
         </p:nvSpPr>
         <p:spPr>
           <a:xfrm>
-            <a:off x="8275320" y="1874520"/>
-            <a:ext cx="1920240" cy="1005840"/>
+            <a:off x="8092440" y="1874520"/>
+            <a:ext cx="1737360" cy="1005840"/>
           </a:xfrm>
           <a:prstGeom prst="rect">
             <a:avLst/>
@@ -18883,6 +19442,14 @@
               </a:rPr>
               <a:t>4,079 test-negative crew quarantined in single rooms in 11 hotels</a:t>
             </a:r>
+            <a:r>
+              <a:rPr lang="en-US" sz="1350" baseline="30000" dirty="0">
+                <a:solidFill>
+                  <a:schemeClr val="tx1"/>
+                </a:solidFill>
+              </a:rPr>
+              <a:t>1</a:t>
+            </a:r>
             <a:endParaRPr lang="en-US" sz="1350" dirty="0"/>
           </a:p>
         </p:txBody>
@@ -18895,7 +19462,7 @@
         </p:nvSpPr>
         <p:spPr>
           <a:xfrm>
-            <a:off x="11183112" y="2907792"/>
+            <a:off x="10725912" y="2907792"/>
             <a:ext cx="310896" cy="310896"/>
           </a:xfrm>
           <a:prstGeom prst="ellipse">
@@ -18920,8 +19487,8 @@
         </p:nvSpPr>
         <p:spPr>
           <a:xfrm>
-            <a:off x="10378440" y="3383280"/>
-            <a:ext cx="1920240" cy="411480"/>
+            <a:off x="10012680" y="3383280"/>
+            <a:ext cx="1737360" cy="411480"/>
           </a:xfrm>
           <a:prstGeom prst="rect">
             <a:avLst/>
@@ -18959,8 +19526,8 @@
         </p:nvSpPr>
         <p:spPr>
           <a:xfrm>
-            <a:off x="10378440" y="3794760"/>
-            <a:ext cx="1920240" cy="1005840"/>
+            <a:off x="10012680" y="3794760"/>
+            <a:ext cx="1737360" cy="1005840"/>
           </a:xfrm>
           <a:prstGeom prst="rect">
             <a:avLst/>
@@ -18981,7 +19548,15 @@
                   <a:schemeClr val="tx1"/>
                 </a:solidFill>
               </a:rPr>
-              <a:t>End of analysis; cases kept occurring at least 6 weeks after docking</a:t>
+              <a:t>End of analysis; cases continued at least 6 weeks after docking</a:t>
+            </a:r>
+            <a:r>
+              <a:rPr lang="en-US" sz="1350" baseline="30000" dirty="0">
+                <a:solidFill>
+                  <a:schemeClr val="tx1"/>
+                </a:solidFill>
+              </a:rPr>
+              <a:t>1</a:t>
             </a:r>
             <a:endParaRPr lang="en-US" sz="1350" dirty="0"/>
           </a:p>
@@ -19041,16 +19616,21 @@
               </a:rPr>
               <a:t>Key point: </a:t>
             </a:r>
-            <a:pPr indent="0" marL="0">
-              <a:buNone/>
-            </a:pPr>
             <a:r>
               <a:rPr lang="en-US" sz="1600" dirty="0">
                 <a:solidFill>
                   <a:schemeClr val="tx1"/>
                 </a:solidFill>
               </a:rPr>
-              <a:t>symptomatic infections were already circulating 12 days before the outbreak was recognized, and spread continued long after the crew left the ship.</a:t>
+              <a:t>symptomatic infections were already circulating 12 days before the outbreak was recognized, and cases continued for at least 6 weeks after the ship docked in Guam.</a:t>
+            </a:r>
+            <a:r>
+              <a:rPr lang="en-US" sz="1600" baseline="30000" dirty="0">
+                <a:solidFill>
+                  <a:schemeClr val="tx1"/>
+                </a:solidFill>
+              </a:rPr>
+              <a:t>1</a:t>
             </a:r>
             <a:endParaRPr lang="en-US" sz="1600" dirty="0"/>
           </a:p>
@@ -19199,7 +19779,7 @@
                   <a:schemeClr val="accent6"/>
                 </a:solidFill>
               </a:rPr>
-              <a:t>Sources: Hu B, et al. Nat Rev Microbiol. 2021; Lauer SA, et al. Ann Intern Med. 2020; He X, et al. Nat Med. 2020.</a:t>
+              <a:t>1. Kasper MR, et al. N Engl J Med. 2020.  2. Hu B, et al. Nat Rev Microbiol. 2021.  3. Lauer SA, et al. Ann Intern Med. 2020.  4. He X, et al. Nat Med. 2020.</a:t>
             </a:r>
             <a:endParaRPr lang="en-US" sz="1000" dirty="0"/>
           </a:p>
@@ -19344,7 +19924,15 @@
                   <a:schemeClr val="tx1"/>
                 </a:solidFill>
               </a:rPr>
-              <a:t>Family Coronaviridae, genus Betacoronavirus</a:t>
+              <a:t>Genus Betacoronavirus, subgenus Sarbecovirus</a:t>
+            </a:r>
+            <a:r>
+              <a:rPr lang="en-US" sz="1450" baseline="30000" dirty="0">
+                <a:solidFill>
+                  <a:schemeClr val="tx1"/>
+                </a:solidFill>
+              </a:rPr>
+              <a:t>2</a:t>
             </a:r>
             <a:endParaRPr lang="en-US" sz="1500" dirty="0"/>
           </a:p>
@@ -19362,7 +19950,15 @@
                   <a:schemeClr val="tx1"/>
                 </a:solidFill>
               </a:rPr>
-              <a:t>Enveloped, positive-sense single-stranded RNA virus</a:t>
+              <a:t>Enveloped RNA virus; 79% genome identity with SARS-CoV</a:t>
+            </a:r>
+            <a:r>
+              <a:rPr lang="en-US" sz="1450" baseline="30000" dirty="0">
+                <a:solidFill>
+                  <a:schemeClr val="tx1"/>
+                </a:solidFill>
+              </a:rPr>
+              <a:t>2</a:t>
             </a:r>
             <a:endParaRPr lang="en-US" sz="1500" dirty="0"/>
           </a:p>
@@ -19380,7 +19976,15 @@
                   <a:schemeClr val="tx1"/>
                 </a:solidFill>
               </a:rPr>
-              <a:t>Spike protein binds the ACE2 receptor in the respiratory tract</a:t>
+              <a:t>Spike protein binds the human ACE2 receptor</a:t>
+            </a:r>
+            <a:r>
+              <a:rPr lang="en-US" sz="1450" baseline="30000" dirty="0">
+                <a:solidFill>
+                  <a:schemeClr val="tx1"/>
+                </a:solidFill>
+              </a:rPr>
+              <a:t>2</a:t>
             </a:r>
             <a:endParaRPr lang="en-US" sz="1500" dirty="0"/>
           </a:p>
@@ -19398,7 +20002,15 @@
                   <a:schemeClr val="tx1"/>
                 </a:solidFill>
               </a:rPr>
-              <a:t>Probable bat reservoir; zoonotic spillover, then sustained human-to-human spread</a:t>
+              <a:t>Closest relatives are horseshoe bat coronaviruses, pointing to a bat reservoir</a:t>
+            </a:r>
+            <a:r>
+              <a:rPr lang="en-US" sz="1450" baseline="30000" dirty="0">
+                <a:solidFill>
+                  <a:schemeClr val="tx1"/>
+                </a:solidFill>
+              </a:rPr>
+              <a:t>2</a:t>
             </a:r>
             <a:endParaRPr lang="en-US" sz="1500" dirty="0"/>
           </a:p>
@@ -19543,7 +20155,15 @@
                   <a:schemeClr val="tx1"/>
                 </a:solidFill>
               </a:rPr>
-              <a:t>Respiratory droplets and aerosols during close contact</a:t>
+              <a:t>Respiratory droplets released during close contact, including speech</a:t>
+            </a:r>
+            <a:r>
+              <a:rPr lang="en-US" sz="1450" baseline="30000" dirty="0">
+                <a:solidFill>
+                  <a:schemeClr val="tx1"/>
+                </a:solidFill>
+              </a:rPr>
+              <a:t>2</a:t>
             </a:r>
             <a:endParaRPr lang="en-US" sz="1500" dirty="0"/>
           </a:p>
@@ -19561,7 +20181,15 @@
                   <a:schemeClr val="tx1"/>
                 </a:solidFill>
               </a:rPr>
-              <a:t>Aerosols build up in crowded, poorly ventilated indoor spaces</a:t>
+              <a:t>Aerosol particles can linger in the air and be inhaled deep into the lungs</a:t>
+            </a:r>
+            <a:r>
+              <a:rPr lang="en-US" sz="1450" baseline="30000" dirty="0">
+                <a:solidFill>
+                  <a:schemeClr val="tx1"/>
+                </a:solidFill>
+              </a:rPr>
+              <a:t>2</a:t>
             </a:r>
             <a:endParaRPr lang="en-US" sz="1500" dirty="0"/>
           </a:p>
@@ -19579,7 +20207,15 @@
                   <a:schemeClr val="tx1"/>
                 </a:solidFill>
               </a:rPr>
-              <a:t>Contaminated surfaces play a smaller role</a:t>
+              <a:t>Coronaviruses can persist on inanimate surfaces for days</a:t>
+            </a:r>
+            <a:r>
+              <a:rPr lang="en-US" sz="1450" baseline="30000" dirty="0">
+                <a:solidFill>
+                  <a:schemeClr val="tx1"/>
+                </a:solidFill>
+              </a:rPr>
+              <a:t>2</a:t>
             </a:r>
             <a:endParaRPr lang="en-US" sz="1500" dirty="0"/>
           </a:p>
@@ -19597,7 +20233,15 @@
                   <a:schemeClr val="tx1"/>
                 </a:solidFill>
               </a:rPr>
-              <a:t>Envelope makes it sensitive to soap, alcohol and disinfectants</a:t>
+              <a:t>Transmissible during mild or asymptomatic infection</a:t>
+            </a:r>
+            <a:r>
+              <a:rPr lang="en-US" sz="1450" baseline="30000" dirty="0">
+                <a:solidFill>
+                  <a:schemeClr val="tx1"/>
+                </a:solidFill>
+              </a:rPr>
+              <a:t>2</a:t>
             </a:r>
             <a:endParaRPr lang="en-US" sz="1500" dirty="0"/>
           </a:p>
@@ -19744,6 +20388,14 @@
               </a:rPr>
               <a:t>Incubation: median 5.1 days; 97.5% develop symptoms within 11.5 days</a:t>
             </a:r>
+            <a:r>
+              <a:rPr lang="en-US" sz="1450" baseline="30000" dirty="0">
+                <a:solidFill>
+                  <a:schemeClr val="tx1"/>
+                </a:solidFill>
+              </a:rPr>
+              <a:t>3</a:t>
+            </a:r>
             <a:endParaRPr lang="en-US" sz="1500" dirty="0"/>
           </a:p>
           <a:p>
@@ -19760,7 +20412,15 @@
                   <a:schemeClr val="tx1"/>
                 </a:solidFill>
               </a:rPr>
-              <a:t>Infectiousness starts 2–3 days before symptoms and peaks around onset</a:t>
+              <a:t>Infectiousness rises about 5–6 days before symptom onset and peaks at onset</a:t>
+            </a:r>
+            <a:r>
+              <a:rPr lang="en-US" sz="1450" baseline="30000" dirty="0">
+                <a:solidFill>
+                  <a:schemeClr val="tx1"/>
+                </a:solidFill>
+              </a:rPr>
+              <a:t>4</a:t>
             </a:r>
             <a:endParaRPr lang="en-US" sz="1500" dirty="0"/>
           </a:p>
@@ -19778,7 +20438,15 @@
                   <a:schemeClr val="tx1"/>
                 </a:solidFill>
               </a:rPr>
-              <a:t>An estimated 44% of transmission happens before symptoms start</a:t>
+              <a:t>An estimated 44% (95% CI, 30%–57%) of transmission occurs before symptoms start</a:t>
+            </a:r>
+            <a:r>
+              <a:rPr lang="en-US" sz="1450" baseline="30000" dirty="0">
+                <a:solidFill>
+                  <a:schemeClr val="tx1"/>
+                </a:solidFill>
+              </a:rPr>
+              <a:t>4</a:t>
             </a:r>
             <a:endParaRPr lang="en-US" sz="1500" dirty="0"/>
           </a:p>
@@ -19796,7 +20464,15 @@
                   <a:schemeClr val="tx1"/>
                 </a:solidFill>
               </a:rPr>
-              <a:t>Diagnosed by rRT-PCR (N1/N2 nucleocapsid gene targets)</a:t>
+              <a:t>Diagnosed by rRT-PCR targeting the N1 and N2 nucleocapsid genes</a:t>
+            </a:r>
+            <a:r>
+              <a:rPr lang="en-US" sz="1450" baseline="30000" dirty="0">
+                <a:solidFill>
+                  <a:schemeClr val="tx1"/>
+                </a:solidFill>
+              </a:rPr>
+              <a:t>1</a:t>
             </a:r>
             <a:endParaRPr lang="en-US" sz="1500" dirty="0"/>
           </a:p>
@@ -19834,9 +20510,6 @@
               </a:rPr>
               <a:t>Relevance to this outbreak: </a:t>
             </a:r>
-            <a:pPr indent="0" marL="0">
-              <a:buNone/>
-            </a:pPr>
             <a:r>
               <a:rPr lang="en-US" sz="1600" dirty="0">
                 <a:solidFill>
@@ -19992,7 +20665,7 @@
                   <a:schemeClr val="accent6"/>
                 </a:solidFill>
               </a:rPr>
-              <a:t>Source: Kasper MR, et al. N Engl J Med. 2020;383:2417-2426.</a:t>
+              <a:t>1. Kasper MR, Geibe JR, Sears CL, et al. N Engl J Med. 2020;383(25):2417-2426.</a:t>
             </a:r>
             <a:endParaRPr lang="en-US" sz="1000" dirty="0"/>
           </a:p>
@@ -20105,7 +20778,23 @@
                   <a:schemeClr val="tx1"/>
                 </a:solidFill>
               </a:rPr>
-              <a:t>of symptomatic cases ever had fever, and only 5.3% at onset. Temperature screening alone would miss most infections.</a:t>
+              <a:t>of symptomatic cases ever had fever, and only 5.3% at onset.</a:t>
+            </a:r>
+            <a:r>
+              <a:rPr lang="en-US" sz="1450" baseline="30000" dirty="0">
+                <a:solidFill>
+                  <a:schemeClr val="tx1"/>
+                </a:solidFill>
+              </a:rPr>
+              <a:t>1</a:t>
+            </a:r>
+            <a:r>
+              <a:rPr lang="en-US" sz="1450" dirty="0">
+                <a:solidFill>
+                  <a:schemeClr val="tx1"/>
+                </a:solidFill>
+              </a:rPr>
+              <a:t> Temperature screening alone would miss most infections.</a:t>
             </a:r>
             <a:endParaRPr lang="en-US" sz="1450" dirty="0"/>
           </a:p>
@@ -20169,6 +20858,14 @@
               </a:rPr>
               <a:t>Cough (32.8%) and headache (31.0%) were the most common first symptoms</a:t>
             </a:r>
+            <a:r>
+              <a:rPr lang="en-US" sz="1450" baseline="30000" dirty="0">
+                <a:solidFill>
+                  <a:schemeClr val="tx1"/>
+                </a:solidFill>
+              </a:rPr>
+              <a:t>1</a:t>
+            </a:r>
             <a:endParaRPr lang="en-US" sz="1500" dirty="0"/>
           </a:p>
           <a:p>
@@ -20187,6 +20884,14 @@
               </a:rPr>
               <a:t>Only 0.5% had oxygen saturation below 95%; none below 90%</a:t>
             </a:r>
+            <a:r>
+              <a:rPr lang="en-US" sz="1450" baseline="30000" dirty="0">
+                <a:solidFill>
+                  <a:schemeClr val="tx1"/>
+                </a:solidFill>
+              </a:rPr>
+              <a:t>1</a:t>
+            </a:r>
             <a:endParaRPr lang="en-US" sz="1500" dirty="0"/>
           </a:p>
           <a:p>
@@ -20204,6 +20909,14 @@
                 </a:solidFill>
               </a:rPr>
               <a:t>Hospitalized sailors more often reported fever (32% vs 12%)</a:t>
+            </a:r>
+            <a:r>
+              <a:rPr lang="en-US" sz="1450" baseline="30000" dirty="0">
+                <a:solidFill>
+                  <a:schemeClr val="tx1"/>
+                </a:solidFill>
+              </a:rPr>
+              <a:t>1</a:t>
             </a:r>
             <a:endParaRPr lang="en-US" sz="1500" dirty="0"/>
           </a:p>
@@ -20352,7 +21065,7 @@
                   <a:schemeClr val="accent6"/>
                 </a:solidFill>
               </a:rPr>
-              <a:t>Source: Kasper MR, et al. N Engl J Med. 2020;383:2417-2426.</a:t>
+              <a:t>1. Kasper MR, Geibe JR, Sears CL, et al. N Engl J Med. 2020;383(25):2417-2426.</a:t>
             </a:r>
             <a:endParaRPr lang="en-US" sz="1000" dirty="0"/>
           </a:p>
@@ -21686,7 +22399,51 @@
       </p:graphicFrame>
       <p:sp>
         <p:nvSpPr>
-          <p:cNvPr id="5" name="criteria card"/>
+          <p:cNvPr id="5" name="Text 2"/>
+          <p:cNvSpPr txBox="1"/>
+          <p:nvPr/>
+        </p:nvSpPr>
+        <p:spPr>
+          <a:xfrm>
+            <a:off x="548640" y="5394960"/>
+            <a:ext cx="6949440" cy="365760"/>
+          </a:xfrm>
+          <a:prstGeom prst="rect">
+            <a:avLst/>
+          </a:prstGeom>
+          <a:noFill/>
+          <a:ln/>
+        </p:spPr>
+        <p:txBody>
+          <a:bodyPr wrap="square" lIns="635" tIns="635" rIns="635" bIns="635" rtlCol="0" anchor="t"/>
+          <a:lstStyle/>
+          <a:p>
+            <a:pPr indent="0" marL="0">
+              <a:buNone/>
+            </a:pPr>
+            <a:r>
+              <a:rPr lang="en-US" sz="1200" i="1" dirty="0">
+                <a:solidFill>
+                  <a:schemeClr val="accent6"/>
+                </a:solidFill>
+              </a:rPr>
+              <a:t>Table: case definitions and case counts as reported by Kasper et al</a:t>
+            </a:r>
+            <a:r>
+              <a:rPr lang="en-US" sz="1200" i="1" baseline="30000" dirty="0">
+                <a:solidFill>
+                  <a:schemeClr val="accent6"/>
+                </a:solidFill>
+              </a:rPr>
+              <a:t>1</a:t>
+            </a:r>
+            <a:endParaRPr lang="en-US" sz="1200" dirty="0"/>
+          </a:p>
+        </p:txBody>
+      </p:sp>
+      <p:sp>
+        <p:nvSpPr>
+          <p:cNvPr id="6" name="criteria card"/>
           <p:cNvSpPr/>
           <p:nvPr/>
         </p:nvSpPr>
@@ -21708,7 +22465,7 @@
       </p:sp>
       <p:sp>
         <p:nvSpPr>
-          <p:cNvPr id="6" name="Text 3"/>
+          <p:cNvPr id="7" name="Text 4"/>
           <p:cNvSpPr txBox="1"/>
           <p:nvPr/>
         </p:nvSpPr>
@@ -21747,7 +22504,7 @@
       </p:sp>
       <p:sp>
         <p:nvSpPr>
-          <p:cNvPr id="7" name="Text 4"/>
+          <p:cNvPr id="8" name="Text 5"/>
           <p:cNvSpPr txBox="1"/>
           <p:nvPr/>
         </p:nvSpPr>
@@ -21781,9 +22538,6 @@
               </a:rPr>
               <a:t>Person: </a:t>
             </a:r>
-            <a:pPr indent="0" marL="0">
-              <a:buNone/>
-            </a:pPr>
             <a:r>
               <a:rPr lang="en-US" sz="1450" dirty="0">
                 <a:solidFill>
@@ -21791,6 +22545,14 @@
                 </a:solidFill>
               </a:rPr>
               <a:t>uniformed crew with a matched personnel ID (civilians excluded)</a:t>
+            </a:r>
+            <a:r>
+              <a:rPr lang="en-US" sz="1450" baseline="30000" dirty="0">
+                <a:solidFill>
+                  <a:schemeClr val="tx1"/>
+                </a:solidFill>
+              </a:rPr>
+              <a:t>1</a:t>
             </a:r>
             <a:endParaRPr lang="en-US" sz="1500" dirty="0"/>
           </a:p>
@@ -21810,9 +22572,6 @@
               </a:rPr>
               <a:t>Place: </a:t>
             </a:r>
-            <a:pPr indent="0" marL="0">
-              <a:buNone/>
-            </a:pPr>
             <a:r>
               <a:rPr lang="en-US" sz="1450" dirty="0">
                 <a:solidFill>
@@ -21820,6 +22579,14 @@
                 </a:solidFill>
               </a:rPr>
               <a:t>U.S.S. Theodore Roosevelt crew, aboard ship or ashore in Guam</a:t>
+            </a:r>
+            <a:r>
+              <a:rPr lang="en-US" sz="1450" baseline="30000" dirty="0">
+                <a:solidFill>
+                  <a:schemeClr val="tx1"/>
+                </a:solidFill>
+              </a:rPr>
+              <a:t>1</a:t>
             </a:r>
             <a:endParaRPr lang="en-US" sz="1500" dirty="0"/>
           </a:p>
@@ -21839,9 +22606,6 @@
               </a:rPr>
               <a:t>Time: </a:t>
             </a:r>
-            <a:pPr indent="0" marL="0">
-              <a:buNone/>
-            </a:pPr>
             <a:r>
               <a:rPr lang="en-US" sz="1450" dirty="0">
                 <a:solidFill>
@@ -21849,6 +22613,14 @@
                 </a:solidFill>
               </a:rPr>
               <a:t>positive tests March 23 – May 18, 2020</a:t>
+            </a:r>
+            <a:r>
+              <a:rPr lang="en-US" sz="1450" baseline="30000" dirty="0">
+                <a:solidFill>
+                  <a:schemeClr val="tx1"/>
+                </a:solidFill>
+              </a:rPr>
+              <a:t>1</a:t>
             </a:r>
             <a:endParaRPr lang="en-US" sz="1500" dirty="0"/>
           </a:p>
@@ -21868,9 +22640,6 @@
               </a:rPr>
               <a:t>Clinical: </a:t>
             </a:r>
-            <a:pPr indent="0" marL="0">
-              <a:buNone/>
-            </a:pPr>
             <a:r>
               <a:rPr lang="en-US" sz="1450" dirty="0">
                 <a:solidFill>
@@ -21878,6 +22647,14 @@
                 </a:solidFill>
               </a:rPr>
               <a:t>CSTE criteria; fever = subjective or ≥100.0°F</a:t>
+            </a:r>
+            <a:r>
+              <a:rPr lang="en-US" sz="1450" baseline="30000" dirty="0">
+                <a:solidFill>
+                  <a:schemeClr val="tx1"/>
+                </a:solidFill>
+              </a:rPr>
+              <a:t>1</a:t>
             </a:r>
             <a:endParaRPr lang="en-US" sz="1500" dirty="0"/>
           </a:p>
@@ -21897,9 +22674,6 @@
               </a:rPr>
               <a:t>Laboratory: </a:t>
             </a:r>
-            <a:pPr indent="0" marL="0">
-              <a:buNone/>
-            </a:pPr>
             <a:r>
               <a:rPr lang="en-US" sz="1450" dirty="0">
                 <a:solidFill>
@@ -21907,6 +22681,14 @@
                 </a:solidFill>
               </a:rPr>
               <a:t>rRT-PCR on NP swab, N1/N2 gene targets</a:t>
+            </a:r>
+            <a:r>
+              <a:rPr lang="en-US" sz="1450" baseline="30000" dirty="0">
+                <a:solidFill>
+                  <a:schemeClr val="tx1"/>
+                </a:solidFill>
+              </a:rPr>
+              <a:t>1</a:t>
             </a:r>
             <a:endParaRPr lang="en-US" sz="1500" dirty="0"/>
           </a:p>
@@ -22055,7 +22837,7 @@
                   <a:schemeClr val="accent6"/>
                 </a:solidFill>
               </a:rPr>
-              <a:t>Analysis based on Kasper MR, et al. N Engl J Med. 2020 (Figure 1 and Discussion).</a:t>
+              <a:t>1. Kasper MR, Geibe JR, Sears CL, et al. N Engl J Med. 2020;383(25):2417-2426. Appraisal is the student's own.</a:t>
             </a:r>
             <a:endParaRPr lang="en-US" sz="1000" dirty="0"/>
           </a:p>
@@ -22220,6 +23002,14 @@
               </a:rPr>
               <a:t>Picked up 572 asymptomatic infections that symptom-based surveillance would have missed</a:t>
             </a:r>
+            <a:r>
+              <a:rPr lang="en-US" sz="1400" baseline="30000" dirty="0">
+                <a:solidFill>
+                  <a:schemeClr val="tx1"/>
+                </a:solidFill>
+              </a:rPr>
+              <a:t>1</a:t>
+            </a:r>
             <a:endParaRPr lang="en-US" sz="1500" dirty="0"/>
           </a:p>
           <a:p>
@@ -22401,6 +23191,14 @@
               </a:rPr>
               <a:t>Suspected tier: less specific. Rhinovirus, RSV and coronavirus OC43 were circulating aboard</a:t>
             </a:r>
+            <a:r>
+              <a:rPr lang="en-US" sz="1400" baseline="30000" dirty="0">
+                <a:solidFill>
+                  <a:schemeClr val="tx1"/>
+                </a:solidFill>
+              </a:rPr>
+              <a:t>1</a:t>
+            </a:r>
             <a:endParaRPr lang="en-US" sz="1500" dirty="0"/>
           </a:p>
           <a:p>
@@ -22418,6 +23216,14 @@
                 </a:solidFill>
               </a:rPr>
               <a:t>Only 60 suspected cases (4.5%), so the effect is small</a:t>
+            </a:r>
+            <a:r>
+              <a:rPr lang="en-US" sz="1400" baseline="30000" dirty="0">
+                <a:solidFill>
+                  <a:schemeClr val="tx1"/>
+                </a:solidFill>
+              </a:rPr>
+              <a:t>1</a:t>
             </a:r>
             <a:endParaRPr lang="en-US" sz="1500" dirty="0"/>
           </a:p>
@@ -22564,6 +23370,14 @@
               </a:rPr>
               <a:t>The CDC/CSTE case definition was revised in April 2020, mid-outbreak</a:t>
             </a:r>
+            <a:r>
+              <a:rPr lang="en-US" sz="1400" baseline="30000" dirty="0">
+                <a:solidFill>
+                  <a:schemeClr val="tx1"/>
+                </a:solidFill>
+              </a:rPr>
+              <a:t>1</a:t>
+            </a:r>
             <a:endParaRPr lang="en-US" sz="1500" dirty="0"/>
           </a:p>
           <a:p>
@@ -22580,7 +23394,23 @@
                   <a:schemeClr val="tx1"/>
                 </a:solidFill>
               </a:rPr>
-              <a:t>Symptom subtypes relied on self-report and on records that were weaker early on, so misclassification is possible</a:t>
+              <a:t>Symptom subtypes relied on self-report and on records that were weaker early on</a:t>
+            </a:r>
+            <a:r>
+              <a:rPr lang="en-US" sz="1400" baseline="30000" dirty="0">
+                <a:solidFill>
+                  <a:schemeClr val="tx1"/>
+                </a:solidFill>
+              </a:rPr>
+              <a:t>1</a:t>
+            </a:r>
+            <a:r>
+              <a:rPr lang="en-US" sz="1400" dirty="0">
+                <a:solidFill>
+                  <a:schemeClr val="tx1"/>
+                </a:solidFill>
+              </a:rPr>
+              <a:t>, so misclassification is possible</a:t>
             </a:r>
             <a:endParaRPr lang="en-US" sz="1500" dirty="0"/>
           </a:p>
@@ -22640,16 +23470,29 @@
               </a:rPr>
               <a:t>My analysis: </a:t>
             </a:r>
-            <a:pPr indent="0" marL="0">
-              <a:buNone/>
-            </a:pPr>
             <a:r>
               <a:rPr lang="en-US" sz="1450" dirty="0">
                 <a:solidFill>
                   <a:schemeClr val="bg1"/>
                 </a:solidFill>
               </a:rPr>
-              <a:t>Figure 1 divides the subtype counts by 1,331 (confirmed + suspected), so it reports 43.0% asymptomatic. Among confirmed cases the figure is 572/1,271 = 45.0%, which matches the abstract's 'nearly half'. A denominator should always be stated.</a:t>
+              <a:t>Figure 1 divides the subtype counts by 1,331 (confirmed + suspected), so it reports 43.0% asymptomatic,</a:t>
+            </a:r>
+            <a:r>
+              <a:rPr lang="en-US" sz="1450" baseline="30000" dirty="0">
+                <a:solidFill>
+                  <a:schemeClr val="bg1"/>
+                </a:solidFill>
+              </a:rPr>
+              <a:t>1</a:t>
+            </a:r>
+            <a:r>
+              <a:rPr lang="en-US" sz="1450" dirty="0">
+                <a:solidFill>
+                  <a:schemeClr val="bg1"/>
+                </a:solidFill>
+              </a:rPr>
+              <a:t> while the Results text calls these shares of confirmed cases. Among confirmed cases the figure is 572/1,271 = 45.0%, which matches the abstract's 'nearly half'. A denominator should always be stated.</a:t>
             </a:r>
             <a:endParaRPr lang="en-US" sz="1450" dirty="0"/>
           </a:p>
@@ -22798,7 +23641,7 @@
                   <a:schemeClr val="accent6"/>
                 </a:solidFill>
               </a:rPr>
-              <a:t>Source: Kasper MR, et al. N Engl J Med. 2020;383:2417-2426.</a:t>
+              <a:t>1. Kasper MR, Geibe JR, Sears CL, et al. N Engl J Med. 2020;383(25):2417-2426.</a:t>
             </a:r>
             <a:endParaRPr lang="en-US" sz="1000" dirty="0"/>
           </a:p>
@@ -22941,6 +23784,14 @@
               </a:rPr>
               <a:t>3 symptomatic sailors tested PCR positive on day 13 at sea</a:t>
             </a:r>
+            <a:r>
+              <a:rPr lang="en-US" sz="1350" baseline="30000" dirty="0">
+                <a:solidFill>
+                  <a:schemeClr val="tx1"/>
+                </a:solidFill>
+              </a:rPr>
+              <a:t>1</a:t>
+            </a:r>
             <a:endParaRPr lang="en-US" sz="1350" dirty="0"/>
           </a:p>
         </p:txBody>
@@ -23102,6 +23953,14 @@
               </a:rPr>
               <a:t>Contact tracing (~400 in 24 h), then testing of all 4,779 crew: active case finding</a:t>
             </a:r>
+            <a:r>
+              <a:rPr lang="en-US" sz="1350" baseline="30000" dirty="0">
+                <a:solidFill>
+                  <a:schemeClr val="tx1"/>
+                </a:solidFill>
+              </a:rPr>
+              <a:t>1</a:t>
+            </a:r>
             <a:endParaRPr lang="en-US" sz="1350" dirty="0"/>
           </a:p>
         </p:txBody>
@@ -23263,6 +24122,14 @@
               </a:rPr>
               <a:t>Personnel rosters linked to demographics, health records and symptom data</a:t>
             </a:r>
+            <a:r>
+              <a:rPr lang="en-US" sz="1350" baseline="30000" dirty="0">
+                <a:solidFill>
+                  <a:schemeClr val="tx1"/>
+                </a:solidFill>
+              </a:rPr>
+              <a:t>1</a:t>
+            </a:r>
             <a:endParaRPr lang="en-US" sz="1350" dirty="0"/>
           </a:p>
         </p:txBody>
@@ -23424,6 +24291,14 @@
               </a:rPr>
               <a:t>NP swabs; rRT-PCR (Seegene Allplex or CDC EUA assay); BioFire panel for other respiratory viruses</a:t>
             </a:r>
+            <a:r>
+              <a:rPr lang="en-US" sz="1350" baseline="30000" dirty="0">
+                <a:solidFill>
+                  <a:schemeClr val="tx1"/>
+                </a:solidFill>
+              </a:rPr>
+              <a:t>1</a:t>
+            </a:r>
             <a:endParaRPr lang="en-US" sz="1350" dirty="0"/>
           </a:p>
         </p:txBody>
@@ -23585,6 +24460,14 @@
               </a:rPr>
               <a:t>Whole-crew cohort; univariate ORs with 95% CIs (OpenEpi, SAS 9.4)</a:t>
             </a:r>
+            <a:r>
+              <a:rPr lang="en-US" sz="1350" baseline="30000" dirty="0">
+                <a:solidFill>
+                  <a:schemeClr val="tx1"/>
+                </a:solidFill>
+              </a:rPr>
+              <a:t>1</a:t>
+            </a:r>
             <a:endParaRPr lang="en-US" sz="1350" dirty="0"/>
           </a:p>
         </p:txBody>
@@ -23643,16 +24526,21 @@
               </a:rPr>
               <a:t>Active surveillance: </a:t>
             </a:r>
-            <a:pPr indent="0" marL="0">
-              <a:buNone/>
-            </a:pPr>
             <a:r>
               <a:rPr lang="en-US" sz="1400" dirty="0">
                 <a:solidFill>
                   <a:schemeClr val="tx1"/>
                 </a:solidFill>
               </a:rPr>
-              <a:t>in-person checks twice daily (symptoms, temperature, pulse oximetry) plus the MySymptoms self-report app; data reviewed at 9 a.m. and 9 p.m.</a:t>
+              <a:t>in-person health screenings plus the MySymptoms self-report app, reviewed every morning and evening; isolated cases also had twice-daily temperature and pulse-oximetry checks</a:t>
+            </a:r>
+            <a:r>
+              <a:rPr lang="en-US" sz="1400" baseline="30000" dirty="0">
+                <a:solidFill>
+                  <a:schemeClr val="tx1"/>
+                </a:solidFill>
+              </a:rPr>
+              <a:t>1</a:t>
             </a:r>
             <a:endParaRPr lang="en-US" sz="1400" dirty="0"/>
           </a:p>
@@ -23712,16 +24600,29 @@
               </a:rPr>
               <a:t>Environmental investigation: </a:t>
             </a:r>
-            <a:pPr indent="0" marL="0">
-              <a:buNone/>
-            </a:pPr>
             <a:r>
               <a:rPr lang="en-US" sz="1400" dirty="0">
                 <a:solidFill>
                   <a:schemeClr val="tx1"/>
                 </a:solidFill>
               </a:rPr>
-              <a:t>not reported. There was no ventilation or surface sampling; spaces were compared only through the department analysis.</a:t>
+              <a:t>none is described in the article</a:t>
+            </a:r>
+            <a:r>
+              <a:rPr lang="en-US" sz="1400" baseline="30000" dirty="0">
+                <a:solidFill>
+                  <a:schemeClr val="tx1"/>
+                </a:solidFill>
+              </a:rPr>
+              <a:t>1</a:t>
+            </a:r>
+            <a:r>
+              <a:rPr lang="en-US" sz="1400" dirty="0">
+                <a:solidFill>
+                  <a:schemeClr val="tx1"/>
+                </a:solidFill>
+              </a:rPr>
+              <a:t>; ventilation and shared spaces were assessed only indirectly, through the department analysis.</a:t>
             </a:r>
             <a:endParaRPr lang="en-US" sz="1400" dirty="0"/>
           </a:p>

</xml_diff>

<commit_message>
Fix citation accuracy and AMA placement found in source check
Correct claims on slides 5, 6, 17, 19 and 20 to match their cited
sources, move superscripts outside commas, list reference 2 in the
slide 14 footer, and add the group author to reference 5.

Co-Authored-By: Claude Opus 5.5 <noreply@anthropic.com>
Claude-Session: https://claude.ai/code/session_01P9P15cYAyKTkYNvJxrcFNV
</commit_message>
<xml_diff>
--- a/Outbreak_of_the_Day/Covid19_Aircraft_Carrier_Outbreak.pptx
+++ b/Outbreak_of_the_Day/Covid19_Aircraft_Carrier_Outbreak.pptx
@@ -127,37 +127,37 @@
   <p:extLst>
     <p:ext uri="{521415D9-36F7-43E2-AB2F-B90AF26B5E84}">
       <p14:sectionLst xmlns:p14="http://schemas.microsoft.com/office/powerpoint/2010/main">
-        <p14:section name="Title" id="{953184c3-7e00-2cba-9e66-e48337aeb26d}">
+        <p14:section name="Title" id="{bd81f4df-bd8f-7e07-1abd-31b0aa2a6f8c}">
           <p14:sldIdLst>
             <p14:sldId id="256"/>
           </p14:sldIdLst>
         </p14:section>
-        <p14:section name="A. Background &amp; Setting" id="{0920f93c-fdbd-5e6f-2613-5ca4a429ee5e}">
+        <p14:section name="A. Background &amp; Setting" id="{a088fbee-dce3-9914-da7e-31015e652cfd}">
           <p14:sldIdLst>
             <p14:sldId id="257"/>
             <p14:sldId id="258"/>
             <p14:sldId id="259"/>
           </p14:sldIdLst>
         </p14:section>
-        <p14:section name="B. Agent &amp; Biology" id="{9a1039ba-fb2a-56ec-2db3-74d08a167395}">
+        <p14:section name="B. Agent &amp; Biology" id="{fcbdfecd-f1c7-b073-53c6-e02eeebba79f}">
           <p14:sldIdLst>
             <p14:sldId id="260"/>
             <p14:sldId id="261"/>
           </p14:sldIdLst>
         </p14:section>
-        <p14:section name="C. Case Definition" id="{5f344063-ab7a-6c95-9632-ff8baa6850b0}">
+        <p14:section name="C. Case Definition" id="{fca86e58-c559-88db-610f-7bf5c5d6d564}">
           <p14:sldIdLst>
             <p14:sldId id="262"/>
             <p14:sldId id="263"/>
           </p14:sldIdLst>
         </p14:section>
-        <p14:section name="D. Investigation Methods" id="{c754e0e8-cd35-27d6-a418-587d1ffa7093}">
+        <p14:section name="D. Investigation Methods" id="{290f16ca-2810-42e6-7a9b-f1da920eb197}">
           <p14:sldIdLst>
             <p14:sldId id="264"/>
             <p14:sldId id="265"/>
           </p14:sldIdLst>
         </p14:section>
-        <p14:section name="E. Epidemiologic Findings" id="{46f0b607-62b5-cab0-9a61-3cafbc1f2c92}">
+        <p14:section name="E. Epidemiologic Findings" id="{629ec605-2b77-0982-e730-7d1b7c3cc245}">
           <p14:sldIdLst>
             <p14:sldId id="266"/>
             <p14:sldId id="267"/>
@@ -165,33 +165,33 @@
             <p14:sldId id="269"/>
           </p14:sldIdLst>
         </p14:section>
-        <p14:section name="G. Epidemiologic Measures" id="{4bec43b5-2865-d5a7-7cc6-e5ef8c8a8277}">
+        <p14:section name="G. Epidemiologic Measures" id="{f492ce4e-f0b8-aabf-d80f-c9778787c046}">
           <p14:sldIdLst>
             <p14:sldId id="270"/>
             <p14:sldId id="271"/>
           </p14:sldIdLst>
         </p14:section>
-        <p14:section name="H. Interpretation" id="{c2592c22-f1fd-0cc4-f5df-b76fa454b185}">
+        <p14:section name="H. Interpretation" id="{2c4f5831-03f2-3d6b-d5ef-733b3e0ec0b1}">
           <p14:sldIdLst>
             <p14:sldId id="272"/>
           </p14:sldIdLst>
         </p14:section>
-        <p14:section name="K–L. Strengths &amp; Limitations" id="{cfe5c5f1-542c-1a3d-1a1d-49b5189567ba}">
+        <p14:section name="K–L. Strengths &amp; Limitations" id="{9b518f45-51ca-978f-002d-5f27216e7caa}">
           <p14:sldIdLst>
             <p14:sldId id="273"/>
           </p14:sldIdLst>
         </p14:section>
-        <p14:section name="M. Recommendations" id="{af0f7a32-b888-4cc5-0fce-94078b908a86}">
+        <p14:section name="M. Recommendations" id="{e2dfce4c-3bc9-35c0-253d-b3b58933a881}">
           <p14:sldIdLst>
             <p14:sldId id="274"/>
           </p14:sldIdLst>
         </p14:section>
-        <p14:section name="N. Conclusion" id="{ac1057f0-83ad-26f2-c42d-4db1e256f5fc}">
+        <p14:section name="N. Conclusion" id="{e69793f8-35ee-b159-5620-a4daeea3e0c4}">
           <p14:sldIdLst>
             <p14:sldId id="275"/>
           </p14:sldIdLst>
         </p14:section>
-        <p14:section name="References" id="{60a9a13f-4a5d-25c9-1611-cb3062e112e2}">
+        <p14:section name="References" id="{1d98693d-7d67-dc12-e058-14744667ec0b}">
           <p14:sldIdLst>
             <p14:sldId id="276"/>
           </p14:sldIdLst>
@@ -231,7 +231,7 @@
                 </a:solidFill>
                 <a:latin typeface="+mn-lt"/>
               </a:rPr>
-              <a:t>Symptoms ever reported, % of symptomatic cases (n = 759)¹</a:t>
+              <a:t>Selected symptoms ever reported, % of symptomatic cases (n = 759)¹</a:t>
             </a:r>
           </a:p>
         </c:rich>
@@ -2414,7 +2414,7 @@
           <a:p>
             <a:r>
               <a:rPr lang="en-US" dirty="0"/>
-              <a:t>Putting it together: the most important finding is that silent carriers and close quarters facilitated rapid spread. The source of introduction was never pinned down. The mode of transmission is well supported by several lines of evidence: the propagated curve, the crowding gradient by rank and department, and the lower rate in PPE-protected medical staff. Is the confined-space association causal? Several Bradford Hill criteria support it: strength, biological plausibility, and consistency with the Navy–CDC serosurvey on the same ship, which tied infection to shared berthing and close contact, although it did not look at work spaces. A dose-response gradient can't be assessed, because confinement was recorded only as confined or mixed. But department is confounded by rank and berthing, the analysis is unadjusted, and many comparisons were made. So I'd call it a strong, plausible association, not proven causation.</a:t>
+              <a:t>Putting it together: the most important finding is that silent carriers and close quarters facilitated rapid spread. The source of introduction was never pinned down. The mode of transmission is well supported by several lines of evidence: the propagated curve, the crowding gradient by rank and department, and the lower rate in PPE-protected medical staff. Is the confined-space association causal? Several Bradford Hill criteria support it: strength, biological plausibility, and consistency with the Navy–CDC serosurvey on the same ship, which tied infection to sharing a berth with an infected crewmate and to contact with a known case, although it did not look at work spaces. A dose-response gradient can't be assessed, because confinement was recorded only as confined or mixed. But department is confounded by rank and berthing, the analysis is unadjusted, and many comparisons were made. So I'd call it a strong, plausible association, not proven causation.</a:t>
             </a:r>
             <a:endParaRPr lang="en-US" dirty="0"/>
           </a:p>
@@ -2590,7 +2590,7 @@
           <a:p>
             <a:r>
               <a:rPr lang="en-US" dirty="0"/>
-              <a:t>Each recommendation follows from a finding. Because most cases had no symptoms, control must rely on testing everyone rather than on symptom screening. Because confined spaces carried 2.6 times the risk, prevention should target ventilation and cohorting in those departments, along with pre-deployment quarantine and testing. Because fever was rare, temperature screening is a poor surveillance tool. Crews need to hear that feeling well is not the same as being uninfected. Future investigations should add genomic sequencing, an environmental assessment and adjusted analyses. The Navy's own experience supports these measures: after adopting them, it deployed ships without another serious outbreak.</a:t>
+              <a:t>Each recommendation follows from a finding. Because most cases had no symptoms, control must rely on testing everyone rather than on symptom screening. Because confined spaces carried 2.6 times the risk, prevention should target ventilation and cohorting in those departments, along with pre-deployment quarantine and testing. Because fever was rare, temperature screening is a poor surveillance tool. Crews need to hear that feeling well is not the same as being uninfected. Future investigations should add genomic sequencing, an environmental assessment and adjusted analyses. The Navy reports that since it adopted pre-deployment restriction of movement with exit testing, cut shore leave at foreign ports and enforced masks, distancing and cohorting on board, it has deployed multiple ships without another serious outbreak. That is encouraging, but it is an uncontrolled observation, and the Navy did not report adopting the ventilation, pooled-screening or sequencing measures I recommend.</a:t>
             </a:r>
             <a:endParaRPr lang="en-US" dirty="0"/>
           </a:p>
@@ -2766,7 +2766,7 @@
           <a:p>
             <a:r>
               <a:rPr lang="en-US" dirty="0"/>
-              <a:t>To sum up: SARS-CoV-2 spread through more than a quarter of the Theodore Roosevelt's crew in about eight weeks. Those affected were young and healthy, with higher risk for enlisted sailors and those in confined spaces. Transmission was propagated person-to-person respiratory spread, supported by the curve shape, the crowding gradient and the protective effect of PPE. The single most important finding is that more than three-quarters of infected sailors had no symptoms when diagnosed. The lesson extends well beyond the Navy, to dormitories, prisons, nursing homes and workplaces: assume silent introduction and build control around testing and the environment, not symptoms. Thank you.</a:t>
+              <a:t>To sum up: SARS-CoV-2 spread through more than a quarter of the Theodore Roosevelt's crew in about eight weeks. Those affected were young and healthy, with higher risk for enlisted sailors and those in confined spaces. Transmission was propagated person-to-person respiratory spread, supported by the curve shape, the crowding gradient and the protective effect of PPE. The single most important finding is that more than three-quarters of infected sailors had no symptoms when diagnosed. The lesson extends well beyond the Navy, to dormitories, prisons, nursing homes and workplaces: assume silent introduction, as the investigators recommend, and build control around testing and the environment, not symptoms. Thank you.</a:t>
             </a:r>
             <a:endParaRPr lang="en-US" dirty="0"/>
           </a:p>
@@ -8726,7 +8726,7 @@
                   <a:schemeClr val="accent6"/>
                 </a:solidFill>
               </a:rPr>
-              <a:t>1. Kasper MR, Geibe JR, Sears CL, et al. N Engl J Med. 2020;383(25):2417-2426. Interpretation is the student's.</a:t>
+              <a:t>1. Kasper MR, et al. N Engl J Med. 2020.  2. Hu B, et al. Nat Rev Microbiol. 2021.  Interpretation is the student's.</a:t>
             </a:r>
             <a:endParaRPr lang="en-US" sz="1000" dirty="0"/>
           </a:p>
@@ -8911,7 +8911,7 @@
                   <a:schemeClr val="tx1"/>
                 </a:solidFill>
               </a:rPr>
-              <a:t>first onsets Mar 11–12, 2–7 days after the port visit and on the same days as the first COD arrivals</a:t>
+              <a:t>first onsets Mar 11–12, 2–7 days after the port visit and on the same days as the first COD arrivals,</a:t>
             </a:r>
             <a:r>
               <a:rPr lang="en-US" sz="1350" baseline="30000" dirty="0">
@@ -8927,7 +8927,7 @@
                   <a:schemeClr val="tx1"/>
                 </a:solidFill>
               </a:rPr>
-              <a:t>, so the port visit fits better</a:t>
+              <a:t> so the port visit fits better</a:t>
             </a:r>
             <a:endParaRPr lang="en-US" sz="1500" dirty="0"/>
           </a:p>
@@ -14050,7 +14050,7 @@
                   <a:schemeClr val="tx1"/>
                 </a:solidFill>
               </a:rPr>
-              <a:t>Navy–CDC serosurvey (n = 382) linked infection to shared berthing (OR 3.3) and close contact</a:t>
+              <a:t>Navy–CDC serosurvey (n = 382) linked infection to sharing a berth with an infected crewmate (OR 3.3) and contact with a known case</a:t>
             </a:r>
             <a:r>
               <a:rPr lang="en-US" sz="1400" baseline="30000" dirty="0">
@@ -15985,7 +15985,7 @@
                   <a:schemeClr val="accent4"/>
                 </a:solidFill>
               </a:rPr>
-              <a:t>Evidence it works: </a:t>
+              <a:t>Navy experience: </a:t>
             </a:r>
             <a:r>
               <a:rPr lang="en-US" sz="1400" dirty="0">
@@ -15993,7 +15993,7 @@
                   <a:schemeClr val="bg1"/>
                 </a:solidFill>
               </a:rPr>
-              <a:t>after the Navy adopted pre-deployment quarantine, testing and reduced port visits, it deployed multiple ships without another serious outbreak.</a:t>
+              <a:t>after adding pre-deployment restriction of movement with exit PCR, cutting shore leave at foreign ports, and enforcing masks, distancing and cohorting, the Navy deployed multiple ships without another serious outbreak.</a:t>
             </a:r>
             <a:r>
               <a:rPr lang="en-US" sz="1400" baseline="30000" dirty="0">
@@ -17521,7 +17521,7 @@
                   <a:schemeClr val="bg1"/>
                 </a:solidFill>
               </a:rPr>
-              <a:t>77% had no symptoms when they tested positive; 45% never had symptoms</a:t>
+              <a:t>77% had no symptoms when they tested positive</a:t>
             </a:r>
             <a:r>
               <a:rPr lang="en-US" sz="1700" baseline="30000" dirty="0">
@@ -17530,6 +17530,14 @@
                 </a:solidFill>
               </a:rPr>
               <a:t>1</a:t>
+            </a:r>
+            <a:r>
+              <a:rPr lang="en-US" sz="1700" dirty="0">
+                <a:solidFill>
+                  <a:schemeClr val="bg1"/>
+                </a:solidFill>
+              </a:rPr>
+              <a:t>; 45% never had symptoms (student calculation)</a:t>
             </a:r>
             <a:endParaRPr lang="en-US" sz="1700" dirty="0"/>
           </a:p>
@@ -17565,7 +17573,7 @@
                   <a:schemeClr val="accent3"/>
                 </a:solidFill>
               </a:rPr>
-              <a:t>1. Kasper MR, Geibe JR, Sears CL, et al. N Engl J Med. 2020;383(25):2417-2426.</a:t>
+              <a:t>1. Kasper MR, Geibe JR, Sears CL, et al. N Engl J Med. 2020;383(25):2417-2426. 45%: student calculation from reference 1 data.</a:t>
             </a:r>
             <a:endParaRPr lang="en-US" sz="1000" dirty="0"/>
           </a:p>
@@ -17631,7 +17639,23 @@
                   <a:schemeClr val="bg1"/>
                 </a:solidFill>
               </a:rPr>
-              <a:t>in any crowded setting, assume the virus is already present and spreading silently. Control has to rely on testing, cohorting and ventilation, not on waiting for symptoms.</a:t>
+              <a:t>in any crowded setting, assume the virus is already present and spreading silently.</a:t>
+            </a:r>
+            <a:r>
+              <a:rPr lang="en-US" sz="1700" baseline="30000" dirty="0">
+                <a:solidFill>
+                  <a:schemeClr val="bg1"/>
+                </a:solidFill>
+              </a:rPr>
+              <a:t>1</a:t>
+            </a:r>
+            <a:r>
+              <a:rPr lang="en-US" sz="1700" dirty="0">
+                <a:solidFill>
+                  <a:schemeClr val="bg1"/>
+                </a:solidFill>
+              </a:rPr>
+              <a:t> Control has to rely on testing, cohorting and ventilation, not on waiting for symptoms.</a:t>
             </a:r>
             <a:endParaRPr lang="en-US" sz="1700" dirty="0"/>
           </a:p>
@@ -17954,7 +17978,7 @@
                   <a:schemeClr val="tx1"/>
                 </a:solidFill>
               </a:rPr>
-              <a:t>Payne DC, Smith-Jeffcoat SE, Nowak G, et al. SARS-CoV-2 infections and serologic responses from a sample of U.S. Navy service members — USS Theodore Roosevelt, April 2020. </a:t>
+              <a:t>Payne DC, Smith-Jeffcoat SE, Nowak G, et al; CDC COVID-19 Surge Laboratory Group. SARS-CoV-2 infections and serologic responses from a sample of U.S. Navy service members — USS Theodore Roosevelt, April 2020. </a:t>
             </a:r>
             <a:r>
               <a:rPr lang="en-US" sz="1500" i="1" dirty="0">
@@ -20386,7 +20410,7 @@
                   <a:schemeClr val="tx1"/>
                 </a:solidFill>
               </a:rPr>
-              <a:t>Incubation: median 5.1 days; 97.5% develop symptoms within 11.5 days</a:t>
+              <a:t>Incubation: median 5.1 days (97.5th percentile, 11.5 days)</a:t>
             </a:r>
             <a:r>
               <a:rPr lang="en-US" sz="1450" baseline="30000" dirty="0">
@@ -20464,7 +20488,7 @@
                   <a:schemeClr val="tx1"/>
                 </a:solidFill>
               </a:rPr>
-              <a:t>Diagnosed by rRT-PCR targeting the N1 and N2 nucleocapsid genes</a:t>
+              <a:t>Diagnosed by rRT-PCR targeting two regions (N1, N2) of the nucleocapsid gene</a:t>
             </a:r>
             <a:r>
               <a:rPr lang="en-US" sz="1450" baseline="30000" dirty="0">
@@ -20679,7 +20703,7 @@
         </p:nvGraphicFramePr>
         <p:xfrm>
           <a:off x="548640" y="1280160"/>
-          <a:ext cx="6675120" cy="4846320"/>
+          <a:ext cx="6675120" cy="4434840"/>
         </p:xfrm>
         <a:graphic xmlns:a="http://schemas.openxmlformats.org/drawingml/2006/main">
           <a:graphicData uri="http://schemas.openxmlformats.org/drawingml/2006/chart">
@@ -20689,7 +20713,51 @@
       </p:graphicFrame>
       <p:sp>
         <p:nvSpPr>
-          <p:cNvPr id="5" name="fever callout"/>
+          <p:cNvPr id="5" name="Text 2"/>
+          <p:cNvSpPr txBox="1"/>
+          <p:nvPr/>
+        </p:nvSpPr>
+        <p:spPr>
+          <a:xfrm>
+            <a:off x="548640" y="5760720"/>
+            <a:ext cx="6675120" cy="411480"/>
+          </a:xfrm>
+          <a:prstGeom prst="rect">
+            <a:avLst/>
+          </a:prstGeom>
+          <a:noFill/>
+          <a:ln/>
+        </p:spPr>
+        <p:txBody>
+          <a:bodyPr wrap="square" lIns="635" tIns="635" rIns="635" bIns="635" rtlCol="0" anchor="t"/>
+          <a:lstStyle/>
+          <a:p>
+            <a:pPr indent="0" marL="0">
+              <a:buNone/>
+            </a:pPr>
+            <a:r>
+              <a:rPr lang="en-US" sz="1200" i="1" dirty="0">
+                <a:solidFill>
+                  <a:schemeClr val="accent6"/>
+                </a:solidFill>
+              </a:rPr>
+              <a:t>Not shown: sore throat (~40%), body aches (~36%), fatigue (~19%) and runny nose (~17%); see Kasper et al Figure 3</a:t>
+            </a:r>
+            <a:r>
+              <a:rPr lang="en-US" sz="1200" i="1" baseline="30000" dirty="0">
+                <a:solidFill>
+                  <a:schemeClr val="accent6"/>
+                </a:solidFill>
+              </a:rPr>
+              <a:t>1</a:t>
+            </a:r>
+            <a:endParaRPr lang="en-US" sz="1200" dirty="0"/>
+          </a:p>
+        </p:txBody>
+      </p:sp>
+      <p:sp>
+        <p:nvSpPr>
+          <p:cNvPr id="6" name="fever callout"/>
           <p:cNvSpPr/>
           <p:nvPr/>
         </p:nvSpPr>
@@ -20711,7 +20779,7 @@
       </p:sp>
       <p:sp>
         <p:nvSpPr>
-          <p:cNvPr id="6" name="Text 3"/>
+          <p:cNvPr id="7" name="Text 4"/>
           <p:cNvSpPr txBox="1"/>
           <p:nvPr/>
         </p:nvSpPr>
@@ -20750,7 +20818,7 @@
       </p:sp>
       <p:sp>
         <p:nvSpPr>
-          <p:cNvPr id="7" name="Text 4"/>
+          <p:cNvPr id="8" name="Text 5"/>
           <p:cNvSpPr txBox="1"/>
           <p:nvPr/>
         </p:nvSpPr>
@@ -20802,7 +20870,7 @@
       </p:sp>
       <p:sp>
         <p:nvSpPr>
-          <p:cNvPr id="8" name="severity callout"/>
+          <p:cNvPr id="9" name="severity callout"/>
           <p:cNvSpPr/>
           <p:nvPr/>
         </p:nvSpPr>
@@ -20824,7 +20892,7 @@
       </p:sp>
       <p:sp>
         <p:nvSpPr>
-          <p:cNvPr id="9" name="Text 6"/>
+          <p:cNvPr id="10" name="Text 7"/>
           <p:cNvSpPr txBox="1"/>
           <p:nvPr/>
         </p:nvSpPr>
@@ -23394,7 +23462,7 @@
                   <a:schemeClr val="tx1"/>
                 </a:solidFill>
               </a:rPr>
-              <a:t>Symptom subtypes relied on self-report and on records that were weaker early on</a:t>
+              <a:t>Symptom subtypes relied on self-report and on records that were weaker early on,</a:t>
             </a:r>
             <a:r>
               <a:rPr lang="en-US" sz="1400" baseline="30000" dirty="0">
@@ -23410,7 +23478,7 @@
                   <a:schemeClr val="tx1"/>
                 </a:solidFill>
               </a:rPr>
-              <a:t>, so misclassification is possible</a:t>
+              <a:t> so misclassification is possible</a:t>
             </a:r>
             <a:endParaRPr lang="en-US" sz="1500" dirty="0"/>
           </a:p>

</xml_diff>